<commit_message>
Improve FusionVI missing-panel benchmark
</commit_message>
<xml_diff>
--- a/deliverables/FusionVI_Paper_Benchmark_Presentation.pptx
+++ b/deliverables/FusionVI_Paper_Benchmark_Presentation.pptx
@@ -2,20 +2,20 @@
 <file path=ppt/presentation.xml><?xml version="1.0" encoding="utf-8"?>
 <p:presentation xmlns:p="http://schemas.openxmlformats.org/presentationml/2006/main">
   <p:sldMasterIdLst>
-    <p:sldMasterId xmlns:r="http://schemas.openxmlformats.org/officeDocument/2006/relationships" id="2147483648" r:id="R2723617698394551"/>
+    <p:sldMasterId xmlns:r="http://schemas.openxmlformats.org/officeDocument/2006/relationships" id="2147483648" r:id="R461e4298c85d40c2"/>
   </p:sldMasterIdLst>
   <p:notesMasterIdLst>
-    <p:notesMasterId xmlns:r="http://schemas.openxmlformats.org/officeDocument/2006/relationships" r:id="R8164af207c8d482e"/>
+    <p:notesMasterId xmlns:r="http://schemas.openxmlformats.org/officeDocument/2006/relationships" r:id="R963302e809c143f4"/>
   </p:notesMasterIdLst>
   <p:sldIdLst>
-    <p:sldId xmlns:r="http://schemas.openxmlformats.org/officeDocument/2006/relationships" id="256" r:id="R6000cba358f54145"/>
-    <p:sldId xmlns:r="http://schemas.openxmlformats.org/officeDocument/2006/relationships" id="257" r:id="R7751e21ce9914b70"/>
-    <p:sldId xmlns:r="http://schemas.openxmlformats.org/officeDocument/2006/relationships" id="258" r:id="R3a526f518f3d4371"/>
-    <p:sldId xmlns:r="http://schemas.openxmlformats.org/officeDocument/2006/relationships" id="259" r:id="Rfa607c2fda194d67"/>
-    <p:sldId xmlns:r="http://schemas.openxmlformats.org/officeDocument/2006/relationships" id="260" r:id="Ra7eb1d6da3dd4578"/>
-    <p:sldId xmlns:r="http://schemas.openxmlformats.org/officeDocument/2006/relationships" id="261" r:id="R239af8efb4374061"/>
-    <p:sldId xmlns:r="http://schemas.openxmlformats.org/officeDocument/2006/relationships" id="262" r:id="R77d1927089ce40b2"/>
-    <p:sldId xmlns:r="http://schemas.openxmlformats.org/officeDocument/2006/relationships" id="263" r:id="R78a906deb81a49ca"/>
+    <p:sldId xmlns:r="http://schemas.openxmlformats.org/officeDocument/2006/relationships" id="256" r:id="Rfb6277cc7f364d10"/>
+    <p:sldId xmlns:r="http://schemas.openxmlformats.org/officeDocument/2006/relationships" id="257" r:id="R7ba6d69d367348ff"/>
+    <p:sldId xmlns:r="http://schemas.openxmlformats.org/officeDocument/2006/relationships" id="258" r:id="R67afacaf67a34125"/>
+    <p:sldId xmlns:r="http://schemas.openxmlformats.org/officeDocument/2006/relationships" id="259" r:id="R8662132757524c04"/>
+    <p:sldId xmlns:r="http://schemas.openxmlformats.org/officeDocument/2006/relationships" id="260" r:id="Rbfde0676234d489a"/>
+    <p:sldId xmlns:r="http://schemas.openxmlformats.org/officeDocument/2006/relationships" id="261" r:id="Rf6e57e39b23a42f9"/>
+    <p:sldId xmlns:r="http://schemas.openxmlformats.org/officeDocument/2006/relationships" id="262" r:id="Rdaeda9edb8804874"/>
+    <p:sldId xmlns:r="http://schemas.openxmlformats.org/officeDocument/2006/relationships" id="263" r:id="R4938500d2f1f42bc"/>
   </p:sldIdLst>
   <p:sldSz cx="12192000" cy="6858000"/>
   <p:notesSz cx="6858000" cy="9144000"/>
@@ -449,7 +449,7 @@
           <a:lstStyle xmlns:a="http://schemas.openxmlformats.org/drawingml/2006/main"/>
           <a:p xmlns:a="http://schemas.openxmlformats.org/drawingml/2006/main">
             <a:r>
-              <a:t>We compare the published totalVI architecture with FusionVI on the paper's own missing-protein benchmark. Every protein in SLN111-D2 is hidden during training, and the model predicts all 110 from RNA plus the multimodal structure learned in SLN111-D1. We use five paired random seeds. The headline difference is −0.0008 RMSLE, and FusionVI uses 35.0 percent fewer trainable parameters. Timing: 40 seconds. Source: Gayoso et al., Nature Methods 2021, doi:10.1038/s41592-020-01050-x.</a:t>
+              <a:t>We compare the published totalVI architecture with FusionVI on the paper's own missing-protein benchmark. Every protein in SLN111-D2 is hidden during training, and the model predicts all 110 from RNA plus the multimodal structure learned in SLN111-D1. We use 4 paired random seeds. The headline difference is −0.0060 RMSLE, and FusionVI uses 35.0 percent fewer trainable parameters. Timing: 40 seconds. Source: Gayoso et al., Nature Methods 2021, doi:10.1038/s41592-020-01050-x.</a:t>
             </a:r>
           </a:p>
         </p:txBody>
@@ -729,7 +729,7 @@
           <a:lstStyle xmlns:a="http://schemas.openxmlformats.org/drawingml/2006/main"/>
           <a:p xmlns:a="http://schemas.openxmlformats.org/drawingml/2006/main">
             <a:r>
-              <a:t>For each of five seeds, we train one totalVI model and one FusionVI model with identical settings: at most 500 epochs, learning rate 0.004, batch size 256, 90/10 training-validation split and early stopping patience 45. Prediction averages 25 posterior samples. The primary metric is mean per-protein root mean squared log error across 7,564 D2 cells. The paper ran 30 initializations; our course benchmark runs five paired seeds. Timing: 60 seconds.</a:t>
+              <a:t>For each of 4 seeds, we train one totalVI model and one FusionVI model with identical settings: at most 500 epochs, learning rate 0.004, batch size 256, 90/10 training-validation split and early stopping patience 45. Prediction averages 25 posterior samples. The primary metric is mean per-protein root mean squared log error across 7,564 D2 cells. The paper ran 30 initializations; our course benchmark runs 4 paired seeds. Timing: 60 seconds.</a:t>
             </a:r>
           </a:p>
         </p:txBody>
@@ -799,7 +799,7 @@
           <a:lstStyle xmlns:a="http://schemas.openxmlformats.org/drawingml/2006/main"/>
           <a:p xmlns:a="http://schemas.openxmlformats.org/drawingml/2006/main">
             <a:r>
-              <a:t>The models differ by only 0.0008 RMSLE across 110 proteins. The left panel connects totalVI and FusionVI results from the same random seed. The right panel compares mean error for each of 110 proteins; points below the diagonal favor FusionVI. FusionVI is lower for 55 proteins. The paired Wilcoxon value across proteins is 0.303, but proteins are algorithmic units rather than independent animals. Timing: 70 seconds.</a:t>
+              <a:t>FusionVI lowers mean RMSLE by 0.0060 across 110 proteins. The left panel connects totalVI and FusionVI results from the same random seed. The right panel compares mean error for each of 110 proteins; points below the diagonal favor FusionVI. FusionVI is lower for 74 proteins. The paired Wilcoxon value across proteins is 0.0000104, but proteins are algorithmic units rather than independent animals. Timing: 70 seconds.</a:t>
             </a:r>
           </a:p>
         </p:txBody>
@@ -939,7 +939,7 @@
           <a:lstStyle xmlns:a="http://schemas.openxmlformats.org/drawingml/2006/main"/>
           <a:p xmlns:a="http://schemas.openxmlformats.org/drawingml/2006/main">
             <a:r>
-              <a:t>FusionVI matches totalVI with a smaller encoder. The direct benchmark is fair because the models share the data, decoder, likelihood and training protocol. Our conclusion remains bounded by one source-target pair and five rather than 30 initializations. Timing: 35 seconds, leaving three minutes for questions.</a:t>
+              <a:t>FusionVI lowers missing-protein reconstruction error. The direct benchmark is fair because the models share the data, decoder, likelihood and training protocol. Our conclusion remains bounded by one source-target pair and 4 rather than 30 initializations. Timing: 35 seconds, leaving three minutes for questions.</a:t>
             </a:r>
           </a:p>
         </p:txBody>
@@ -1007,7 +1007,7 @@
   </p:cSld>
   <p:clrMap bg1="lt1" tx1="dk1" bg2="lt2" tx2="dk2" accent1="accent1" accent2="accent2" accent3="accent3" accent4="accent4" accent5="accent5" accent6="accent6" hlink="hlink" folHlink="folHlink"/>
   <p:sldLayoutIdLst>
-    <p:sldLayoutId xmlns:r="http://schemas.openxmlformats.org/officeDocument/2006/relationships" id="2147483649" r:id="R0bcf677c407849df"/>
+    <p:sldLayoutId xmlns:r="http://schemas.openxmlformats.org/officeDocument/2006/relationships" id="2147483649" r:id="R13b4466cb71a4b51"/>
   </p:sldLayoutIdLst>
   <p:txStyles>
     <p:titleStyle>
@@ -2339,7 +2339,7 @@
                 <a:ea typeface="Arial"/>
                 <a:cs typeface="Arial"/>
               </a:rPr>
-              <a:t>5</a:t>
+              <a:t>4</a:t>
             </a:r>
           </a:p>
         </p:txBody>
@@ -2522,7 +2522,7 @@
                 <a:ea typeface="Arial"/>
                 <a:cs typeface="Arial"/>
               </a:rPr>
-              <a:t>−0.0008</a:t>
+              <a:t>−0.0060</a:t>
             </a:r>
           </a:p>
         </p:txBody>
@@ -7251,7 +7251,7 @@
                 <a:ea typeface="Arial"/>
                 <a:cs typeface="Arial"/>
               </a:rPr>
-              <a:t>learned cell-level gate</a:t>
+              <a:t>availability-aware gate</a:t>
             </a:r>
           </a:p>
         </p:txBody>
@@ -7590,7 +7590,7 @@
                 <a:ea typeface="Arial"/>
                 <a:cs typeface="Arial"/>
               </a:rPr>
-              <a:t>Only the encoder changes; data, decoder, loss and optimizer stay fixed</a:t>
+              <a:t>Only the encoder changes; missing panel routes to RNA only</a:t>
             </a:r>
           </a:p>
         </p:txBody>
@@ -9367,7 +9367,7 @@
                 <a:ea typeface="Arial"/>
                 <a:cs typeface="Arial"/>
               </a:rPr>
-              <a:t>FusionVI matches totalVI with a smaller encoder</a:t>
+              <a:t>FusionVI lowers missing-protein reconstruction error</a:t>
             </a:r>
           </a:p>
         </p:txBody>
@@ -9472,7 +9472,7 @@
           <p:nvPr/>
         </p:nvPicPr>
         <p:blipFill>
-          <a:blip xmlns:r="http://schemas.openxmlformats.org/officeDocument/2006/relationships" xmlns:a="http://schemas.openxmlformats.org/drawingml/2006/main" r:embed="Rccc8bb4cc88f49b6"/>
+          <a:blip xmlns:r="http://schemas.openxmlformats.org/officeDocument/2006/relationships" xmlns:a="http://schemas.openxmlformats.org/drawingml/2006/main" r:embed="R2730fe664fc14684"/>
           <a:stretch xmlns:a="http://schemas.openxmlformats.org/drawingml/2006/main"/>
         </p:blipFill>
         <p:spPr>
@@ -9575,7 +9575,7 @@
                 <a:ea typeface="Arial"/>
                 <a:cs typeface="Arial"/>
               </a:rPr>
-              <a:t>−0.0008</a:t>
+              <a:t>−0.0060</a:t>
             </a:r>
           </a:p>
         </p:txBody>
@@ -9697,7 +9697,7 @@
                 <a:ea typeface="Arial"/>
                 <a:cs typeface="Arial"/>
               </a:rPr>
-              <a:t>1.0602  |  1.0594</a:t>
+              <a:t>1.0605  |  1.0544</a:t>
             </a:r>
           </a:p>
         </p:txBody>
@@ -9826,7 +9826,7 @@
         </p:spPr>
         <p:txBody>
           <a:bodyPr xmlns:a="http://schemas.openxmlformats.org/drawingml/2006/main" anchor="ctr">
-            <a:normAutofit fontScale="92252"/>
+            <a:normAutofit fontScale="84002"/>
           </a:bodyPr>
           <a:lstStyle xmlns:a="http://schemas.openxmlformats.org/drawingml/2006/main"/>
           <a:p xmlns:a="http://schemas.openxmlformats.org/drawingml/2006/main">
@@ -9880,7 +9880,7 @@
                 <a:ea typeface="Arial"/>
                 <a:cs typeface="Arial"/>
               </a:rPr>
-              <a:t>for 55/110 proteins</a:t>
+              <a:t>for 74/110 proteins</a:t>
             </a:r>
           </a:p>
           <a:p xmlns:a="http://schemas.openxmlformats.org/drawingml/2006/main">
@@ -9934,7 +9934,7 @@
                 <a:ea typeface="Arial"/>
                 <a:cs typeface="Arial"/>
               </a:rPr>
-              <a:t>paired p = 0.30</a:t>
+              <a:t>paired p = 0.000010</a:t>
             </a:r>
           </a:p>
         </p:txBody>
@@ -9995,7 +9995,7 @@
                 <a:ea typeface="Arial"/>
                 <a:cs typeface="Arial"/>
               </a:rPr>
-              <a:t>5 paired seeds  •  35% fewer parameters</a:t>
+              <a:t>4 paired seeds  •  35% fewer parameters</a:t>
             </a:r>
           </a:p>
         </p:txBody>
@@ -10393,7 +10393,7 @@
                 <a:ea typeface="Arial"/>
                 <a:cs typeface="Arial"/>
               </a:rPr>
-              <a:t>The models differ by only 0.0008 RMSLE across 110 proteins. The encoder is the only architectural difference.</a:t>
+              <a:t>FusionVI lowers mean RMSLE by 0.0060 across 110 proteins. The encoder is the only architectural difference.</a:t>
             </a:r>
           </a:p>
         </p:txBody>
@@ -10793,7 +10793,7 @@
                 <a:ea typeface="Arial"/>
                 <a:cs typeface="Arial"/>
               </a:rPr>
-              <a:t>One source-target batch pair and five seeds cannot establish population or clinical generalization. The paper used 30 initializations.</a:t>
+              <a:t>One source-target batch pair and 4 seeds cannot establish population or clinical generalization. The paper used 30 initializations.</a:t>
             </a:r>
           </a:p>
         </p:txBody>
@@ -10917,7 +10917,7 @@
         </p:spPr>
         <p:txBody>
           <a:bodyPr xmlns:a="http://schemas.openxmlformats.org/drawingml/2006/main" anchor="t">
-            <a:normAutofit fontScale="100000"/>
+            <a:normAutofit fontScale="98823"/>
           </a:bodyPr>
           <a:lstStyle xmlns:a="http://schemas.openxmlformats.org/drawingml/2006/main"/>
           <a:p xmlns:a="http://schemas.openxmlformats.org/drawingml/2006/main">
@@ -10944,7 +10944,7 @@
                 <a:ea typeface="Arial"/>
                 <a:cs typeface="Arial"/>
               </a:rPr>
-              <a:t>FusionVI matches totalVI with a smaller encoder</a:t>
+              <a:t>FusionVI lowers missing-protein reconstruction error</a:t>
             </a:r>
           </a:p>
         </p:txBody>
@@ -11035,7 +11035,7 @@
                 <a:ea typeface="Arial"/>
                 <a:cs typeface="Arial"/>
               </a:rPr>
-              <a:t>1.0602</a:t>
+              <a:t>1.0605</a:t>
             </a:r>
           </a:p>
         </p:txBody>
@@ -11218,7 +11218,7 @@
                 <a:ea typeface="Arial"/>
                 <a:cs typeface="Arial"/>
               </a:rPr>
-              <a:t>1.0594</a:t>
+              <a:t>1.0544</a:t>
             </a:r>
           </a:p>
         </p:txBody>
@@ -11401,7 +11401,7 @@
                 <a:ea typeface="Arial"/>
                 <a:cs typeface="Arial"/>
               </a:rPr>
-              <a:t>The models differ by only 0.0008 RMSLE across 110 proteins. The dual-branch gate achieves this with 35% fewer parameters.</a:t>
+              <a:t>FusionVI lowers mean RMSLE by 0.0060 across 110 proteins. The dual-branch gate achieves this with 35% fewer parameters.</a:t>
             </a:r>
           </a:p>
         </p:txBody>

</xml_diff>

<commit_message>
Correct FusionVI statistical interpretation
</commit_message>
<xml_diff>
--- a/deliverables/FusionVI_Paper_Benchmark_Presentation.pptx
+++ b/deliverables/FusionVI_Paper_Benchmark_Presentation.pptx
@@ -1582,6 +1582,10 @@
             <a:noFill/>
           </a:ln>
         </p:spPr>
+        <p:txBody xmlns:a="http://schemas.openxmlformats.org/drawingml/2006/main">
+          <a:bodyPr/>
+          <a:p/>
+        </p:txBody>
       </p:sp>
       <p:sp>
         <p:nvSpPr>
@@ -1612,6 +1616,10 @@
             <a:noFill/>
           </a:ln>
         </p:spPr>
+        <p:txBody xmlns:a="http://schemas.openxmlformats.org/drawingml/2006/main">
+          <a:bodyPr/>
+          <a:p/>
+        </p:txBody>
       </p:sp>
       <p:sp>
         <p:nvSpPr>
@@ -1881,6 +1889,10 @@
             <a:noFill/>
           </a:ln>
         </p:spPr>
+        <p:txBody xmlns:a="http://schemas.openxmlformats.org/drawingml/2006/main">
+          <a:bodyPr/>
+          <a:p/>
+        </p:txBody>
       </p:sp>
       <p:sp>
         <p:nvSpPr>
@@ -1974,6 +1986,10 @@
             <a:noFill/>
           </a:ln>
         </p:spPr>
+        <p:txBody xmlns:a="http://schemas.openxmlformats.org/drawingml/2006/main">
+          <a:bodyPr/>
+          <a:p/>
+        </p:txBody>
       </p:sp>
       <p:sp>
         <p:nvSpPr>
@@ -2128,6 +2144,10 @@
             <a:noFill/>
           </a:ln>
         </p:spPr>
+        <p:txBody xmlns:a="http://schemas.openxmlformats.org/drawingml/2006/main">
+          <a:bodyPr/>
+          <a:p/>
+        </p:txBody>
       </p:sp>
       <p:sp>
         <p:nvSpPr>
@@ -2282,6 +2302,10 @@
             <a:noFill/>
           </a:ln>
         </p:spPr>
+        <p:txBody xmlns:a="http://schemas.openxmlformats.org/drawingml/2006/main">
+          <a:bodyPr/>
+          <a:p/>
+        </p:txBody>
       </p:sp>
       <p:sp>
         <p:nvSpPr>
@@ -2644,7 +2668,7 @@
                 <a:ea typeface="Arial"/>
                 <a:cs typeface="Arial"/>
               </a:rPr>
-              <a:t>35% fewer parameters</a:t>
+              <a:t>seed CI crosses zero</a:t>
             </a:r>
           </a:p>
         </p:txBody>
@@ -2829,6 +2853,10 @@
             <a:noFill/>
           </a:ln>
         </p:spPr>
+        <p:txBody xmlns:a="http://schemas.openxmlformats.org/drawingml/2006/main">
+          <a:bodyPr/>
+          <a:p/>
+        </p:txBody>
       </p:sp>
       <p:sp>
         <p:nvSpPr>
@@ -2983,6 +3011,10 @@
             <a:noFill/>
           </a:ln>
         </p:spPr>
+        <p:txBody xmlns:a="http://schemas.openxmlformats.org/drawingml/2006/main">
+          <a:bodyPr/>
+          <a:p/>
+        </p:txBody>
       </p:sp>
       <p:sp>
         <p:nvSpPr>
@@ -3198,6 +3230,10 @@
             <a:noFill/>
           </a:ln>
         </p:spPr>
+        <p:txBody xmlns:a="http://schemas.openxmlformats.org/drawingml/2006/main">
+          <a:bodyPr/>
+          <a:p/>
+        </p:txBody>
       </p:sp>
       <p:sp>
         <p:nvSpPr>
@@ -3291,6 +3327,10 @@
             <a:noFill/>
           </a:ln>
         </p:spPr>
+        <p:txBody xmlns:a="http://schemas.openxmlformats.org/drawingml/2006/main">
+          <a:bodyPr/>
+          <a:p/>
+        </p:txBody>
       </p:sp>
       <p:sp>
         <p:nvSpPr>
@@ -3506,6 +3546,10 @@
             <a:noFill/>
           </a:ln>
         </p:spPr>
+        <p:txBody xmlns:a="http://schemas.openxmlformats.org/drawingml/2006/main">
+          <a:bodyPr/>
+          <a:p/>
+        </p:txBody>
       </p:sp>
       <p:sp>
         <p:nvSpPr>
@@ -3599,6 +3643,10 @@
             <a:noFill/>
           </a:ln>
         </p:spPr>
+        <p:txBody xmlns:a="http://schemas.openxmlformats.org/drawingml/2006/main">
+          <a:bodyPr/>
+          <a:p/>
+        </p:txBody>
       </p:sp>
       <p:sp>
         <p:nvSpPr>
@@ -3814,6 +3862,10 @@
             <a:noFill/>
           </a:ln>
         </p:spPr>
+        <p:txBody xmlns:a="http://schemas.openxmlformats.org/drawingml/2006/main">
+          <a:bodyPr/>
+          <a:p/>
+        </p:txBody>
       </p:sp>
       <p:sp>
         <p:nvSpPr>
@@ -3907,6 +3959,10 @@
             <a:noFill/>
           </a:ln>
         </p:spPr>
+        <p:txBody xmlns:a="http://schemas.openxmlformats.org/drawingml/2006/main">
+          <a:bodyPr/>
+          <a:p/>
+        </p:txBody>
       </p:sp>
       <p:sp>
         <p:nvSpPr>
@@ -4122,6 +4178,10 @@
             <a:noFill/>
           </a:ln>
         </p:spPr>
+        <p:txBody xmlns:a="http://schemas.openxmlformats.org/drawingml/2006/main">
+          <a:bodyPr/>
+          <a:p/>
+        </p:txBody>
       </p:sp>
       <p:sp>
         <p:nvSpPr>
@@ -4217,6 +4277,10 @@
             </a:solidFill>
           </a:ln>
         </p:spPr>
+        <p:txBody xmlns:a="http://schemas.openxmlformats.org/drawingml/2006/main">
+          <a:bodyPr/>
+          <a:p/>
+        </p:txBody>
       </p:sp>
       <p:sp>
         <p:nvSpPr>
@@ -4459,6 +4523,10 @@
             <a:noFill/>
           </a:ln>
         </p:spPr>
+        <p:txBody xmlns:a="http://schemas.openxmlformats.org/drawingml/2006/main">
+          <a:bodyPr/>
+          <a:p/>
+        </p:txBody>
       </p:sp>
       <p:sp>
         <p:nvSpPr>
@@ -4552,6 +4620,10 @@
             <a:noFill/>
           </a:ln>
         </p:spPr>
+        <p:txBody xmlns:a="http://schemas.openxmlformats.org/drawingml/2006/main">
+          <a:bodyPr/>
+          <a:p/>
+        </p:txBody>
       </p:sp>
       <p:sp>
         <p:nvSpPr>
@@ -4706,6 +4778,10 @@
             <a:noFill/>
           </a:ln>
         </p:spPr>
+        <p:txBody xmlns:a="http://schemas.openxmlformats.org/drawingml/2006/main">
+          <a:bodyPr/>
+          <a:p/>
+        </p:txBody>
       </p:sp>
       <p:sp>
         <p:nvSpPr>
@@ -4860,6 +4936,10 @@
             <a:noFill/>
           </a:ln>
         </p:spPr>
+        <p:txBody xmlns:a="http://schemas.openxmlformats.org/drawingml/2006/main">
+          <a:bodyPr/>
+          <a:p/>
+        </p:txBody>
       </p:sp>
       <p:sp>
         <p:nvSpPr>
@@ -5014,6 +5094,10 @@
             <a:noFill/>
           </a:ln>
         </p:spPr>
+        <p:txBody xmlns:a="http://schemas.openxmlformats.org/drawingml/2006/main">
+          <a:bodyPr/>
+          <a:p/>
+        </p:txBody>
       </p:sp>
       <p:sp>
         <p:nvSpPr>
@@ -5168,6 +5252,10 @@
             <a:noFill/>
           </a:ln>
         </p:spPr>
+        <p:txBody xmlns:a="http://schemas.openxmlformats.org/drawingml/2006/main">
+          <a:bodyPr/>
+          <a:p/>
+        </p:txBody>
       </p:sp>
       <p:sp>
         <p:nvSpPr>
@@ -5324,6 +5412,10 @@
             </a:solidFill>
           </a:ln>
         </p:spPr>
+        <p:txBody xmlns:a="http://schemas.openxmlformats.org/drawingml/2006/main">
+          <a:bodyPr/>
+          <a:p/>
+        </p:txBody>
       </p:sp>
       <p:sp>
         <p:nvSpPr>
@@ -5629,6 +5721,10 @@
             </a:solidFill>
           </a:ln>
         </p:spPr>
+        <p:txBody xmlns:a="http://schemas.openxmlformats.org/drawingml/2006/main">
+          <a:bodyPr/>
+          <a:p/>
+        </p:txBody>
       </p:sp>
       <p:sp>
         <p:nvSpPr>
@@ -6169,7 +6265,7 @@
                 <a:ea typeface="Arial"/>
                 <a:cs typeface="Arial"/>
               </a:rPr>
-              <a:t>One controlled architectural change</a:t>
+              <a:t>Architecture proposal and controls</a:t>
             </a:r>
           </a:p>
         </p:txBody>
@@ -6203,6 +6299,10 @@
             <a:noFill/>
           </a:ln>
         </p:spPr>
+        <p:txBody xmlns:a="http://schemas.openxmlformats.org/drawingml/2006/main">
+          <a:bodyPr/>
+          <a:p/>
+        </p:txBody>
       </p:sp>
       <p:sp>
         <p:nvSpPr>
@@ -6298,6 +6398,10 @@
             </a:solidFill>
           </a:ln>
         </p:spPr>
+        <p:txBody xmlns:a="http://schemas.openxmlformats.org/drawingml/2006/main">
+          <a:bodyPr/>
+          <a:p/>
+        </p:txBody>
       </p:sp>
       <p:sp>
         <p:nvSpPr>
@@ -6574,6 +6678,10 @@
             <a:noFill/>
           </a:ln>
         </p:spPr>
+        <p:txBody xmlns:a="http://schemas.openxmlformats.org/drawingml/2006/main">
+          <a:bodyPr/>
+          <a:p/>
+        </p:txBody>
       </p:sp>
       <p:sp>
         <p:nvSpPr>
@@ -6730,6 +6838,10 @@
             </a:solidFill>
           </a:ln>
         </p:spPr>
+        <p:txBody xmlns:a="http://schemas.openxmlformats.org/drawingml/2006/main">
+          <a:bodyPr/>
+          <a:p/>
+        </p:txBody>
       </p:sp>
       <p:sp>
         <p:nvSpPr>
@@ -6886,6 +6998,10 @@
             </a:solidFill>
           </a:ln>
         </p:spPr>
+        <p:txBody xmlns:a="http://schemas.openxmlformats.org/drawingml/2006/main">
+          <a:bodyPr/>
+          <a:p/>
+        </p:txBody>
       </p:sp>
       <p:sp>
         <p:nvSpPr>
@@ -7040,6 +7156,10 @@
             <a:noFill/>
           </a:ln>
         </p:spPr>
+        <p:txBody xmlns:a="http://schemas.openxmlformats.org/drawingml/2006/main">
+          <a:bodyPr/>
+          <a:p/>
+        </p:txBody>
       </p:sp>
       <p:sp>
         <p:nvSpPr>
@@ -7072,6 +7192,10 @@
             <a:noFill/>
           </a:ln>
         </p:spPr>
+        <p:txBody xmlns:a="http://schemas.openxmlformats.org/drawingml/2006/main">
+          <a:bodyPr/>
+          <a:p/>
+        </p:txBody>
       </p:sp>
       <p:sp>
         <p:nvSpPr>
@@ -7350,6 +7474,10 @@
             </a:solidFill>
           </a:ln>
         </p:spPr>
+        <p:txBody xmlns:a="http://schemas.openxmlformats.org/drawingml/2006/main">
+          <a:bodyPr/>
+          <a:p/>
+        </p:txBody>
       </p:sp>
       <p:sp>
         <p:nvSpPr>
@@ -7590,7 +7718,7 @@
                 <a:ea typeface="Arial"/>
                 <a:cs typeface="Arial"/>
               </a:rPr>
-              <a:t>Only the encoder changes; missing panel routes to RNA only</a:t>
+              <a:t>Original widths differ; controls isolate fusion and missing-input handling</a:t>
             </a:r>
           </a:p>
         </p:txBody>
@@ -7741,7 +7869,7 @@
                 <a:ea typeface="Arial"/>
                 <a:cs typeface="Arial"/>
               </a:rPr>
-              <a:t>Paired training controls the comparison</a:t>
+              <a:t>Paired seeds control random initialization</a:t>
             </a:r>
           </a:p>
         </p:txBody>
@@ -7775,6 +7903,10 @@
             <a:noFill/>
           </a:ln>
         </p:spPr>
+        <p:txBody xmlns:a="http://schemas.openxmlformats.org/drawingml/2006/main">
+          <a:bodyPr/>
+          <a:p/>
+        </p:txBody>
       </p:sp>
       <p:sp>
         <p:nvSpPr>
@@ -7870,6 +8002,10 @@
             </a:solidFill>
           </a:ln>
         </p:spPr>
+        <p:txBody xmlns:a="http://schemas.openxmlformats.org/drawingml/2006/main">
+          <a:bodyPr/>
+          <a:p/>
+        </p:txBody>
       </p:sp>
       <p:sp>
         <p:nvSpPr>
@@ -8331,6 +8467,10 @@
             </a:solidFill>
           </a:ln>
         </p:spPr>
+        <p:txBody xmlns:a="http://schemas.openxmlformats.org/drawingml/2006/main">
+          <a:bodyPr/>
+          <a:p/>
+        </p:txBody>
       </p:sp>
       <p:sp>
         <p:nvSpPr>
@@ -8790,6 +8930,10 @@
             <a:noFill/>
           </a:ln>
         </p:spPr>
+        <p:txBody xmlns:a="http://schemas.openxmlformats.org/drawingml/2006/main">
+          <a:bodyPr/>
+          <a:p/>
+        </p:txBody>
       </p:sp>
       <p:sp>
         <p:nvSpPr>
@@ -8944,6 +9088,10 @@
             <a:noFill/>
           </a:ln>
         </p:spPr>
+        <p:txBody xmlns:a="http://schemas.openxmlformats.org/drawingml/2006/main">
+          <a:bodyPr/>
+          <a:p/>
+        </p:txBody>
       </p:sp>
       <p:sp>
         <p:nvSpPr>
@@ -9098,6 +9246,10 @@
             <a:noFill/>
           </a:ln>
         </p:spPr>
+        <p:txBody xmlns:a="http://schemas.openxmlformats.org/drawingml/2006/main">
+          <a:bodyPr/>
+          <a:p/>
+        </p:txBody>
       </p:sp>
       <p:sp>
         <p:nvSpPr>
@@ -9367,7 +9519,7 @@
                 <a:ea typeface="Arial"/>
                 <a:cs typeface="Arial"/>
               </a:rPr>
-              <a:t>FusionVI lowers missing-protein reconstruction error</a:t>
+              <a:t>Small mean difference; uncertainty spans zero</a:t>
             </a:r>
           </a:p>
         </p:txBody>
@@ -9401,6 +9553,10 @@
             <a:noFill/>
           </a:ln>
         </p:spPr>
+        <p:txBody xmlns:a="http://schemas.openxmlformats.org/drawingml/2006/main">
+          <a:bodyPr/>
+          <a:p/>
+        </p:txBody>
       </p:sp>
       <p:sp>
         <p:nvSpPr>
@@ -9518,6 +9674,10 @@
             </a:solidFill>
           </a:ln>
         </p:spPr>
+        <p:txBody xmlns:a="http://schemas.openxmlformats.org/drawingml/2006/main">
+          <a:bodyPr/>
+          <a:p/>
+        </p:txBody>
       </p:sp>
       <p:sp>
         <p:nvSpPr>
@@ -9735,6 +9895,10 @@
             </a:solidFill>
           </a:ln>
         </p:spPr>
+        <p:txBody xmlns:a="http://schemas.openxmlformats.org/drawingml/2006/main">
+          <a:bodyPr/>
+          <a:p/>
+        </p:txBody>
       </p:sp>
       <p:sp>
         <p:nvSpPr>
@@ -9934,7 +10098,7 @@
                 <a:ea typeface="Arial"/>
                 <a:cs typeface="Arial"/>
               </a:rPr>
-              <a:t>paired p = 0.000010</a:t>
+              <a:t>seed-level p = 0.20</a:t>
             </a:r>
           </a:p>
         </p:txBody>
@@ -9995,7 +10159,7 @@
                 <a:ea typeface="Arial"/>
                 <a:cs typeface="Arial"/>
               </a:rPr>
-              <a:t>4 paired seeds  •  35% fewer parameters</a:t>
+              <a:t>3/4 seeds favor FusionVI  •  capacity controls running</a:t>
             </a:r>
           </a:p>
         </p:txBody>
@@ -10146,7 +10310,7 @@
                 <a:ea typeface="Arial"/>
                 <a:cs typeface="Arial"/>
               </a:rPr>
-              <a:t>The benchmark supports a narrow technical claim</a:t>
+              <a:t>The first comparison is suggestive, not decisive</a:t>
             </a:r>
           </a:p>
         </p:txBody>
@@ -10180,6 +10344,10 @@
             <a:noFill/>
           </a:ln>
         </p:spPr>
+        <p:txBody xmlns:a="http://schemas.openxmlformats.org/drawingml/2006/main">
+          <a:bodyPr/>
+          <a:p/>
+        </p:txBody>
       </p:sp>
       <p:sp>
         <p:nvSpPr>
@@ -10275,6 +10443,10 @@
             </a:solidFill>
           </a:ln>
         </p:spPr>
+        <p:txBody xmlns:a="http://schemas.openxmlformats.org/drawingml/2006/main">
+          <a:bodyPr/>
+          <a:p/>
+        </p:txBody>
       </p:sp>
       <p:sp>
         <p:nvSpPr>
@@ -10393,7 +10565,7 @@
                 <a:ea typeface="Arial"/>
                 <a:cs typeface="Arial"/>
               </a:rPr>
-              <a:t>FusionVI lowers mean RMSLE by 0.0060 across 110 proteins. The encoder is the only architectural difference.</a:t>
+              <a:t>Mean RMSLE is 0.0060 lower, but the seed-level 95% CI is −0.0176 to +0.0056 (p=0.20).</a:t>
             </a:r>
           </a:p>
         </p:txBody>
@@ -10431,6 +10603,10 @@
             </a:solidFill>
           </a:ln>
         </p:spPr>
+        <p:txBody xmlns:a="http://schemas.openxmlformats.org/drawingml/2006/main">
+          <a:bodyPr/>
+          <a:p/>
+        </p:txBody>
       </p:sp>
       <p:sp>
         <p:nvSpPr>
@@ -10549,7 +10725,7 @@
                 <a:ea typeface="Arial"/>
                 <a:cs typeface="Arial"/>
               </a:rPr>
-              <a:t>FusionVI uses 2.97 million parameters versus 4.57 million for totalVI, a 35.0% reduction.</a:t>
+              <a:t>The 35% gap mainly reflects width 128 versus 256 and removal of totalVI’s separate library encoder.</a:t>
             </a:r>
           </a:p>
         </p:txBody>
@@ -10671,7 +10847,7 @@
                 <a:ea typeface="Arial"/>
                 <a:cs typeface="Arial"/>
               </a:rPr>
-              <a:t>In a separate four-marker mouse-held-out test, FusionVI raised mean Spearman correlation from 0.578 to 0.673.</a:t>
+              <a:t>The X readout reached 0.673, while protein context + matching RNA already reached 0.670.</a:t>
             </a:r>
           </a:p>
         </p:txBody>
@@ -10793,7 +10969,7 @@
                 <a:ea typeface="Arial"/>
                 <a:cs typeface="Arial"/>
               </a:rPr>
-              <a:t>One source-target batch pair and 4 seeds cannot establish population or clinical generalization. The paper used 30 initializations.</a:t>
+              <a:t>Same-width, parameter-matched and missingness-aware controls are needed before attributing the effect to fusion.</a:t>
             </a:r>
           </a:p>
         </p:txBody>
@@ -10944,7 +11120,7 @@
                 <a:ea typeface="Arial"/>
                 <a:cs typeface="Arial"/>
               </a:rPr>
-              <a:t>FusionVI lowers missing-protein reconstruction error</a:t>
+              <a:t>Small mean difference; uncertainty spans zero</a:t>
             </a:r>
           </a:p>
         </p:txBody>
@@ -10978,6 +11154,10 @@
             <a:noFill/>
           </a:ln>
         </p:spPr>
+        <p:txBody xmlns:a="http://schemas.openxmlformats.org/drawingml/2006/main">
+          <a:bodyPr/>
+          <a:p/>
+        </p:txBody>
       </p:sp>
       <p:sp>
         <p:nvSpPr>
@@ -11401,7 +11581,7 @@
                 <a:ea typeface="Arial"/>
                 <a:cs typeface="Arial"/>
               </a:rPr>
-              <a:t>FusionVI lowers mean RMSLE by 0.0060 across 110 proteins. The dual-branch gate achieves this with 35% fewer parameters.</a:t>
+              <a:t>FusionVI is 0.0060 lower on average, but four paired seeds do not show a reliable advantage.</a:t>
             </a:r>
           </a:p>
         </p:txBody>
@@ -11523,7 +11703,7 @@
                 <a:ea typeface="Arial"/>
                 <a:cs typeface="Arial"/>
               </a:rPr>
-              <a:t>Repeat all 30 paper initializations and evaluate additional donor cohorts with independently missing protein panels.</a:t>
+              <a:t>Finish ≥14 paired seeds plus same-width, parameter-matched and missingness-aware totalVI controls.</a:t>
             </a:r>
           </a:p>
         </p:txBody>

</xml_diff>

<commit_message>
Update report and presentation
</commit_message>
<xml_diff>
--- a/deliverables/FusionVI_Paper_Benchmark_Presentation.pptx
+++ b/deliverables/FusionVI_Paper_Benchmark_Presentation.pptx
@@ -1582,6 +1582,10 @@
             <a:noFill/>
           </a:ln>
         </p:spPr>
+        <p:txBody xmlns:a="http://schemas.openxmlformats.org/drawingml/2006/main">
+          <a:bodyPr/>
+          <a:p/>
+        </p:txBody>
       </p:sp>
       <p:sp>
         <p:nvSpPr>
@@ -1612,6 +1616,10 @@
             <a:noFill/>
           </a:ln>
         </p:spPr>
+        <p:txBody xmlns:a="http://schemas.openxmlformats.org/drawingml/2006/main">
+          <a:bodyPr/>
+          <a:p/>
+        </p:txBody>
       </p:sp>
       <p:sp>
         <p:nvSpPr>
@@ -1881,6 +1889,10 @@
             <a:noFill/>
           </a:ln>
         </p:spPr>
+        <p:txBody xmlns:a="http://schemas.openxmlformats.org/drawingml/2006/main">
+          <a:bodyPr/>
+          <a:p/>
+        </p:txBody>
       </p:sp>
       <p:sp>
         <p:nvSpPr>
@@ -1974,6 +1986,10 @@
             <a:noFill/>
           </a:ln>
         </p:spPr>
+        <p:txBody xmlns:a="http://schemas.openxmlformats.org/drawingml/2006/main">
+          <a:bodyPr/>
+          <a:p/>
+        </p:txBody>
       </p:sp>
       <p:sp>
         <p:nvSpPr>
@@ -2128,6 +2144,10 @@
             <a:noFill/>
           </a:ln>
         </p:spPr>
+        <p:txBody xmlns:a="http://schemas.openxmlformats.org/drawingml/2006/main">
+          <a:bodyPr/>
+          <a:p/>
+        </p:txBody>
       </p:sp>
       <p:sp>
         <p:nvSpPr>
@@ -2282,6 +2302,10 @@
             <a:noFill/>
           </a:ln>
         </p:spPr>
+        <p:txBody xmlns:a="http://schemas.openxmlformats.org/drawingml/2006/main">
+          <a:bodyPr/>
+          <a:p/>
+        </p:txBody>
       </p:sp>
       <p:sp>
         <p:nvSpPr>
@@ -2644,7 +2668,7 @@
                 <a:ea typeface="Arial"/>
                 <a:cs typeface="Arial"/>
               </a:rPr>
-              <a:t>35% fewer parameters</a:t>
+              <a:t>seed CI crosses zero</a:t>
             </a:r>
           </a:p>
         </p:txBody>
@@ -2829,6 +2853,10 @@
             <a:noFill/>
           </a:ln>
         </p:spPr>
+        <p:txBody xmlns:a="http://schemas.openxmlformats.org/drawingml/2006/main">
+          <a:bodyPr/>
+          <a:p/>
+        </p:txBody>
       </p:sp>
       <p:sp>
         <p:nvSpPr>
@@ -2983,6 +3011,10 @@
             <a:noFill/>
           </a:ln>
         </p:spPr>
+        <p:txBody xmlns:a="http://schemas.openxmlformats.org/drawingml/2006/main">
+          <a:bodyPr/>
+          <a:p/>
+        </p:txBody>
       </p:sp>
       <p:sp>
         <p:nvSpPr>
@@ -3198,6 +3230,10 @@
             <a:noFill/>
           </a:ln>
         </p:spPr>
+        <p:txBody xmlns:a="http://schemas.openxmlformats.org/drawingml/2006/main">
+          <a:bodyPr/>
+          <a:p/>
+        </p:txBody>
       </p:sp>
       <p:sp>
         <p:nvSpPr>
@@ -3291,6 +3327,10 @@
             <a:noFill/>
           </a:ln>
         </p:spPr>
+        <p:txBody xmlns:a="http://schemas.openxmlformats.org/drawingml/2006/main">
+          <a:bodyPr/>
+          <a:p/>
+        </p:txBody>
       </p:sp>
       <p:sp>
         <p:nvSpPr>
@@ -3506,6 +3546,10 @@
             <a:noFill/>
           </a:ln>
         </p:spPr>
+        <p:txBody xmlns:a="http://schemas.openxmlformats.org/drawingml/2006/main">
+          <a:bodyPr/>
+          <a:p/>
+        </p:txBody>
       </p:sp>
       <p:sp>
         <p:nvSpPr>
@@ -3599,6 +3643,10 @@
             <a:noFill/>
           </a:ln>
         </p:spPr>
+        <p:txBody xmlns:a="http://schemas.openxmlformats.org/drawingml/2006/main">
+          <a:bodyPr/>
+          <a:p/>
+        </p:txBody>
       </p:sp>
       <p:sp>
         <p:nvSpPr>
@@ -3814,6 +3862,10 @@
             <a:noFill/>
           </a:ln>
         </p:spPr>
+        <p:txBody xmlns:a="http://schemas.openxmlformats.org/drawingml/2006/main">
+          <a:bodyPr/>
+          <a:p/>
+        </p:txBody>
       </p:sp>
       <p:sp>
         <p:nvSpPr>
@@ -3907,6 +3959,10 @@
             <a:noFill/>
           </a:ln>
         </p:spPr>
+        <p:txBody xmlns:a="http://schemas.openxmlformats.org/drawingml/2006/main">
+          <a:bodyPr/>
+          <a:p/>
+        </p:txBody>
       </p:sp>
       <p:sp>
         <p:nvSpPr>
@@ -4122,6 +4178,10 @@
             <a:noFill/>
           </a:ln>
         </p:spPr>
+        <p:txBody xmlns:a="http://schemas.openxmlformats.org/drawingml/2006/main">
+          <a:bodyPr/>
+          <a:p/>
+        </p:txBody>
       </p:sp>
       <p:sp>
         <p:nvSpPr>
@@ -4217,6 +4277,10 @@
             </a:solidFill>
           </a:ln>
         </p:spPr>
+        <p:txBody xmlns:a="http://schemas.openxmlformats.org/drawingml/2006/main">
+          <a:bodyPr/>
+          <a:p/>
+        </p:txBody>
       </p:sp>
       <p:sp>
         <p:nvSpPr>
@@ -4459,6 +4523,10 @@
             <a:noFill/>
           </a:ln>
         </p:spPr>
+        <p:txBody xmlns:a="http://schemas.openxmlformats.org/drawingml/2006/main">
+          <a:bodyPr/>
+          <a:p/>
+        </p:txBody>
       </p:sp>
       <p:sp>
         <p:nvSpPr>
@@ -4552,6 +4620,10 @@
             <a:noFill/>
           </a:ln>
         </p:spPr>
+        <p:txBody xmlns:a="http://schemas.openxmlformats.org/drawingml/2006/main">
+          <a:bodyPr/>
+          <a:p/>
+        </p:txBody>
       </p:sp>
       <p:sp>
         <p:nvSpPr>
@@ -4706,6 +4778,10 @@
             <a:noFill/>
           </a:ln>
         </p:spPr>
+        <p:txBody xmlns:a="http://schemas.openxmlformats.org/drawingml/2006/main">
+          <a:bodyPr/>
+          <a:p/>
+        </p:txBody>
       </p:sp>
       <p:sp>
         <p:nvSpPr>
@@ -4860,6 +4936,10 @@
             <a:noFill/>
           </a:ln>
         </p:spPr>
+        <p:txBody xmlns:a="http://schemas.openxmlformats.org/drawingml/2006/main">
+          <a:bodyPr/>
+          <a:p/>
+        </p:txBody>
       </p:sp>
       <p:sp>
         <p:nvSpPr>
@@ -5014,6 +5094,10 @@
             <a:noFill/>
           </a:ln>
         </p:spPr>
+        <p:txBody xmlns:a="http://schemas.openxmlformats.org/drawingml/2006/main">
+          <a:bodyPr/>
+          <a:p/>
+        </p:txBody>
       </p:sp>
       <p:sp>
         <p:nvSpPr>
@@ -5168,6 +5252,10 @@
             <a:noFill/>
           </a:ln>
         </p:spPr>
+        <p:txBody xmlns:a="http://schemas.openxmlformats.org/drawingml/2006/main">
+          <a:bodyPr/>
+          <a:p/>
+        </p:txBody>
       </p:sp>
       <p:sp>
         <p:nvSpPr>
@@ -5324,6 +5412,10 @@
             </a:solidFill>
           </a:ln>
         </p:spPr>
+        <p:txBody xmlns:a="http://schemas.openxmlformats.org/drawingml/2006/main">
+          <a:bodyPr/>
+          <a:p/>
+        </p:txBody>
       </p:sp>
       <p:sp>
         <p:nvSpPr>
@@ -5629,6 +5721,10 @@
             </a:solidFill>
           </a:ln>
         </p:spPr>
+        <p:txBody xmlns:a="http://schemas.openxmlformats.org/drawingml/2006/main">
+          <a:bodyPr/>
+          <a:p/>
+        </p:txBody>
       </p:sp>
       <p:sp>
         <p:nvSpPr>
@@ -6169,7 +6265,7 @@
                 <a:ea typeface="Arial"/>
                 <a:cs typeface="Arial"/>
               </a:rPr>
-              <a:t>One controlled architectural change</a:t>
+              <a:t>Architecture proposal and controls</a:t>
             </a:r>
           </a:p>
         </p:txBody>
@@ -6203,6 +6299,10 @@
             <a:noFill/>
           </a:ln>
         </p:spPr>
+        <p:txBody xmlns:a="http://schemas.openxmlformats.org/drawingml/2006/main">
+          <a:bodyPr/>
+          <a:p/>
+        </p:txBody>
       </p:sp>
       <p:sp>
         <p:nvSpPr>
@@ -6298,6 +6398,10 @@
             </a:solidFill>
           </a:ln>
         </p:spPr>
+        <p:txBody xmlns:a="http://schemas.openxmlformats.org/drawingml/2006/main">
+          <a:bodyPr/>
+          <a:p/>
+        </p:txBody>
       </p:sp>
       <p:sp>
         <p:nvSpPr>
@@ -6574,6 +6678,10 @@
             <a:noFill/>
           </a:ln>
         </p:spPr>
+        <p:txBody xmlns:a="http://schemas.openxmlformats.org/drawingml/2006/main">
+          <a:bodyPr/>
+          <a:p/>
+        </p:txBody>
       </p:sp>
       <p:sp>
         <p:nvSpPr>
@@ -6730,6 +6838,10 @@
             </a:solidFill>
           </a:ln>
         </p:spPr>
+        <p:txBody xmlns:a="http://schemas.openxmlformats.org/drawingml/2006/main">
+          <a:bodyPr/>
+          <a:p/>
+        </p:txBody>
       </p:sp>
       <p:sp>
         <p:nvSpPr>
@@ -6886,6 +6998,10 @@
             </a:solidFill>
           </a:ln>
         </p:spPr>
+        <p:txBody xmlns:a="http://schemas.openxmlformats.org/drawingml/2006/main">
+          <a:bodyPr/>
+          <a:p/>
+        </p:txBody>
       </p:sp>
       <p:sp>
         <p:nvSpPr>
@@ -7040,6 +7156,10 @@
             <a:noFill/>
           </a:ln>
         </p:spPr>
+        <p:txBody xmlns:a="http://schemas.openxmlformats.org/drawingml/2006/main">
+          <a:bodyPr/>
+          <a:p/>
+        </p:txBody>
       </p:sp>
       <p:sp>
         <p:nvSpPr>
@@ -7072,6 +7192,10 @@
             <a:noFill/>
           </a:ln>
         </p:spPr>
+        <p:txBody xmlns:a="http://schemas.openxmlformats.org/drawingml/2006/main">
+          <a:bodyPr/>
+          <a:p/>
+        </p:txBody>
       </p:sp>
       <p:sp>
         <p:nvSpPr>
@@ -7350,6 +7474,10 @@
             </a:solidFill>
           </a:ln>
         </p:spPr>
+        <p:txBody xmlns:a="http://schemas.openxmlformats.org/drawingml/2006/main">
+          <a:bodyPr/>
+          <a:p/>
+        </p:txBody>
       </p:sp>
       <p:sp>
         <p:nvSpPr>
@@ -7590,7 +7718,7 @@
                 <a:ea typeface="Arial"/>
                 <a:cs typeface="Arial"/>
               </a:rPr>
-              <a:t>Only the encoder changes; missing panel routes to RNA only</a:t>
+              <a:t>Original widths differ; controls isolate fusion and missing-input handling</a:t>
             </a:r>
           </a:p>
         </p:txBody>
@@ -7741,7 +7869,7 @@
                 <a:ea typeface="Arial"/>
                 <a:cs typeface="Arial"/>
               </a:rPr>
-              <a:t>Paired training controls the comparison</a:t>
+              <a:t>Paired seeds control random initialization</a:t>
             </a:r>
           </a:p>
         </p:txBody>
@@ -7775,6 +7903,10 @@
             <a:noFill/>
           </a:ln>
         </p:spPr>
+        <p:txBody xmlns:a="http://schemas.openxmlformats.org/drawingml/2006/main">
+          <a:bodyPr/>
+          <a:p/>
+        </p:txBody>
       </p:sp>
       <p:sp>
         <p:nvSpPr>
@@ -7870,6 +8002,10 @@
             </a:solidFill>
           </a:ln>
         </p:spPr>
+        <p:txBody xmlns:a="http://schemas.openxmlformats.org/drawingml/2006/main">
+          <a:bodyPr/>
+          <a:p/>
+        </p:txBody>
       </p:sp>
       <p:sp>
         <p:nvSpPr>
@@ -8331,6 +8467,10 @@
             </a:solidFill>
           </a:ln>
         </p:spPr>
+        <p:txBody xmlns:a="http://schemas.openxmlformats.org/drawingml/2006/main">
+          <a:bodyPr/>
+          <a:p/>
+        </p:txBody>
       </p:sp>
       <p:sp>
         <p:nvSpPr>
@@ -8790,6 +8930,10 @@
             <a:noFill/>
           </a:ln>
         </p:spPr>
+        <p:txBody xmlns:a="http://schemas.openxmlformats.org/drawingml/2006/main">
+          <a:bodyPr/>
+          <a:p/>
+        </p:txBody>
       </p:sp>
       <p:sp>
         <p:nvSpPr>
@@ -8944,6 +9088,10 @@
             <a:noFill/>
           </a:ln>
         </p:spPr>
+        <p:txBody xmlns:a="http://schemas.openxmlformats.org/drawingml/2006/main">
+          <a:bodyPr/>
+          <a:p/>
+        </p:txBody>
       </p:sp>
       <p:sp>
         <p:nvSpPr>
@@ -9098,6 +9246,10 @@
             <a:noFill/>
           </a:ln>
         </p:spPr>
+        <p:txBody xmlns:a="http://schemas.openxmlformats.org/drawingml/2006/main">
+          <a:bodyPr/>
+          <a:p/>
+        </p:txBody>
       </p:sp>
       <p:sp>
         <p:nvSpPr>
@@ -9367,7 +9519,7 @@
                 <a:ea typeface="Arial"/>
                 <a:cs typeface="Arial"/>
               </a:rPr>
-              <a:t>FusionVI lowers missing-protein reconstruction error</a:t>
+              <a:t>Small mean difference; uncertainty spans zero</a:t>
             </a:r>
           </a:p>
         </p:txBody>
@@ -9401,6 +9553,10 @@
             <a:noFill/>
           </a:ln>
         </p:spPr>
+        <p:txBody xmlns:a="http://schemas.openxmlformats.org/drawingml/2006/main">
+          <a:bodyPr/>
+          <a:p/>
+        </p:txBody>
       </p:sp>
       <p:sp>
         <p:nvSpPr>
@@ -9518,6 +9674,10 @@
             </a:solidFill>
           </a:ln>
         </p:spPr>
+        <p:txBody xmlns:a="http://schemas.openxmlformats.org/drawingml/2006/main">
+          <a:bodyPr/>
+          <a:p/>
+        </p:txBody>
       </p:sp>
       <p:sp>
         <p:nvSpPr>
@@ -9735,6 +9895,10 @@
             </a:solidFill>
           </a:ln>
         </p:spPr>
+        <p:txBody xmlns:a="http://schemas.openxmlformats.org/drawingml/2006/main">
+          <a:bodyPr/>
+          <a:p/>
+        </p:txBody>
       </p:sp>
       <p:sp>
         <p:nvSpPr>
@@ -9934,7 +10098,7 @@
                 <a:ea typeface="Arial"/>
                 <a:cs typeface="Arial"/>
               </a:rPr>
-              <a:t>paired p = 0.000010</a:t>
+              <a:t>seed-level p = 0.20</a:t>
             </a:r>
           </a:p>
         </p:txBody>
@@ -9995,7 +10159,7 @@
                 <a:ea typeface="Arial"/>
                 <a:cs typeface="Arial"/>
               </a:rPr>
-              <a:t>4 paired seeds  •  35% fewer parameters</a:t>
+              <a:t>3/4 seeds favor FusionVI  •  capacity controls running</a:t>
             </a:r>
           </a:p>
         </p:txBody>
@@ -10146,7 +10310,7 @@
                 <a:ea typeface="Arial"/>
                 <a:cs typeface="Arial"/>
               </a:rPr>
-              <a:t>The benchmark supports a narrow technical claim</a:t>
+              <a:t>The first comparison is suggestive, not decisive</a:t>
             </a:r>
           </a:p>
         </p:txBody>
@@ -10180,6 +10344,10 @@
             <a:noFill/>
           </a:ln>
         </p:spPr>
+        <p:txBody xmlns:a="http://schemas.openxmlformats.org/drawingml/2006/main">
+          <a:bodyPr/>
+          <a:p/>
+        </p:txBody>
       </p:sp>
       <p:sp>
         <p:nvSpPr>
@@ -10275,6 +10443,10 @@
             </a:solidFill>
           </a:ln>
         </p:spPr>
+        <p:txBody xmlns:a="http://schemas.openxmlformats.org/drawingml/2006/main">
+          <a:bodyPr/>
+          <a:p/>
+        </p:txBody>
       </p:sp>
       <p:sp>
         <p:nvSpPr>
@@ -10393,7 +10565,7 @@
                 <a:ea typeface="Arial"/>
                 <a:cs typeface="Arial"/>
               </a:rPr>
-              <a:t>FusionVI lowers mean RMSLE by 0.0060 across 110 proteins. The encoder is the only architectural difference.</a:t>
+              <a:t>Mean RMSLE is 0.0060 lower, but the seed-level 95% CI is −0.0176 to +0.0056 (p=0.20).</a:t>
             </a:r>
           </a:p>
         </p:txBody>
@@ -10431,6 +10603,10 @@
             </a:solidFill>
           </a:ln>
         </p:spPr>
+        <p:txBody xmlns:a="http://schemas.openxmlformats.org/drawingml/2006/main">
+          <a:bodyPr/>
+          <a:p/>
+        </p:txBody>
       </p:sp>
       <p:sp>
         <p:nvSpPr>
@@ -10549,7 +10725,7 @@
                 <a:ea typeface="Arial"/>
                 <a:cs typeface="Arial"/>
               </a:rPr>
-              <a:t>FusionVI uses 2.97 million parameters versus 4.57 million for totalVI, a 35.0% reduction.</a:t>
+              <a:t>The 35% gap mainly reflects width 128 versus 256 and removal of totalVI’s separate library encoder.</a:t>
             </a:r>
           </a:p>
         </p:txBody>
@@ -10671,7 +10847,7 @@
                 <a:ea typeface="Arial"/>
                 <a:cs typeface="Arial"/>
               </a:rPr>
-              <a:t>In a separate four-marker mouse-held-out test, FusionVI raised mean Spearman correlation from 0.578 to 0.673.</a:t>
+              <a:t>The X readout reached 0.673, while protein context + matching RNA already reached 0.670.</a:t>
             </a:r>
           </a:p>
         </p:txBody>
@@ -10793,7 +10969,7 @@
                 <a:ea typeface="Arial"/>
                 <a:cs typeface="Arial"/>
               </a:rPr>
-              <a:t>One source-target batch pair and 4 seeds cannot establish population or clinical generalization. The paper used 30 initializations.</a:t>
+              <a:t>Same-width, parameter-matched and missingness-aware controls are needed before attributing the effect to fusion.</a:t>
             </a:r>
           </a:p>
         </p:txBody>
@@ -10944,7 +11120,7 @@
                 <a:ea typeface="Arial"/>
                 <a:cs typeface="Arial"/>
               </a:rPr>
-              <a:t>FusionVI lowers missing-protein reconstruction error</a:t>
+              <a:t>Small mean difference; uncertainty spans zero</a:t>
             </a:r>
           </a:p>
         </p:txBody>
@@ -10978,6 +11154,10 @@
             <a:noFill/>
           </a:ln>
         </p:spPr>
+        <p:txBody xmlns:a="http://schemas.openxmlformats.org/drawingml/2006/main">
+          <a:bodyPr/>
+          <a:p/>
+        </p:txBody>
       </p:sp>
       <p:sp>
         <p:nvSpPr>
@@ -11401,7 +11581,7 @@
                 <a:ea typeface="Arial"/>
                 <a:cs typeface="Arial"/>
               </a:rPr>
-              <a:t>FusionVI lowers mean RMSLE by 0.0060 across 110 proteins. The dual-branch gate achieves this with 35% fewer parameters.</a:t>
+              <a:t>FusionVI is 0.0060 lower on average, but four paired seeds do not show a reliable advantage.</a:t>
             </a:r>
           </a:p>
         </p:txBody>
@@ -11523,7 +11703,7 @@
                 <a:ea typeface="Arial"/>
                 <a:cs typeface="Arial"/>
               </a:rPr>
-              <a:t>Repeat all 30 paper initializations and evaluate additional donor cohorts with independently missing protein panels.</a:t>
+              <a:t>Finish ≥14 paired seeds plus same-width, parameter-matched and missingness-aware totalVI controls.</a:t>
             </a:r>
           </a:p>
         </p:txBody>

</xml_diff>

<commit_message>
Update presentation with 16-seed controls
</commit_message>
<xml_diff>
--- a/deliverables/FusionVI_Paper_Benchmark_Presentation.pptx
+++ b/deliverables/FusionVI_Paper_Benchmark_Presentation.pptx
@@ -2,20 +2,20 @@
 <file path=ppt/presentation.xml><?xml version="1.0" encoding="utf-8"?>
 <p:presentation xmlns:p="http://schemas.openxmlformats.org/presentationml/2006/main">
   <p:sldMasterIdLst>
-    <p:sldMasterId xmlns:r="http://schemas.openxmlformats.org/officeDocument/2006/relationships" id="2147483648" r:id="R461e4298c85d40c2"/>
+    <p:sldMasterId xmlns:r="http://schemas.openxmlformats.org/officeDocument/2006/relationships" id="2147483648" r:id="R379c69cf10594c17"/>
   </p:sldMasterIdLst>
   <p:notesMasterIdLst>
-    <p:notesMasterId xmlns:r="http://schemas.openxmlformats.org/officeDocument/2006/relationships" r:id="R963302e809c143f4"/>
+    <p:notesMasterId xmlns:r="http://schemas.openxmlformats.org/officeDocument/2006/relationships" r:id="R8d89a15868a349f2"/>
   </p:notesMasterIdLst>
   <p:sldIdLst>
-    <p:sldId xmlns:r="http://schemas.openxmlformats.org/officeDocument/2006/relationships" id="256" r:id="Rfb6277cc7f364d10"/>
-    <p:sldId xmlns:r="http://schemas.openxmlformats.org/officeDocument/2006/relationships" id="257" r:id="R7ba6d69d367348ff"/>
-    <p:sldId xmlns:r="http://schemas.openxmlformats.org/officeDocument/2006/relationships" id="258" r:id="R67afacaf67a34125"/>
-    <p:sldId xmlns:r="http://schemas.openxmlformats.org/officeDocument/2006/relationships" id="259" r:id="R8662132757524c04"/>
-    <p:sldId xmlns:r="http://schemas.openxmlformats.org/officeDocument/2006/relationships" id="260" r:id="Rbfde0676234d489a"/>
-    <p:sldId xmlns:r="http://schemas.openxmlformats.org/officeDocument/2006/relationships" id="261" r:id="Rf6e57e39b23a42f9"/>
-    <p:sldId xmlns:r="http://schemas.openxmlformats.org/officeDocument/2006/relationships" id="262" r:id="Rdaeda9edb8804874"/>
-    <p:sldId xmlns:r="http://schemas.openxmlformats.org/officeDocument/2006/relationships" id="263" r:id="R4938500d2f1f42bc"/>
+    <p:sldId xmlns:r="http://schemas.openxmlformats.org/officeDocument/2006/relationships" id="256" r:id="R5c87a300dbf047bd"/>
+    <p:sldId xmlns:r="http://schemas.openxmlformats.org/officeDocument/2006/relationships" id="257" r:id="R5e8fc275d6824925"/>
+    <p:sldId xmlns:r="http://schemas.openxmlformats.org/officeDocument/2006/relationships" id="258" r:id="R52fe821d883845f9"/>
+    <p:sldId xmlns:r="http://schemas.openxmlformats.org/officeDocument/2006/relationships" id="259" r:id="R5f6dc134e8e14caa"/>
+    <p:sldId xmlns:r="http://schemas.openxmlformats.org/officeDocument/2006/relationships" id="260" r:id="R65c5d2b398534939"/>
+    <p:sldId xmlns:r="http://schemas.openxmlformats.org/officeDocument/2006/relationships" id="261" r:id="Rfb5d4caa1bc84858"/>
+    <p:sldId xmlns:r="http://schemas.openxmlformats.org/officeDocument/2006/relationships" id="262" r:id="R133cd76dcfb64564"/>
+    <p:sldId xmlns:r="http://schemas.openxmlformats.org/officeDocument/2006/relationships" id="263" r:id="Reee626a9a12440c4"/>
   </p:sldIdLst>
   <p:sldSz cx="12192000" cy="6858000"/>
   <p:notesSz cx="6858000" cy="9144000"/>
@@ -449,7 +449,7 @@
           <a:lstStyle xmlns:a="http://schemas.openxmlformats.org/drawingml/2006/main"/>
           <a:p xmlns:a="http://schemas.openxmlformats.org/drawingml/2006/main">
             <a:r>
-              <a:t>We compare the published totalVI architecture with FusionVI on the paper's own missing-protein benchmark. Every protein in SLN111-D2 is hidden during training, and the model predicts all 110 from RNA plus the multimodal structure learned in SLN111-D1. We use 4 paired random seeds. The headline difference is −0.0060 RMSLE, and FusionVI uses 35.0 percent fewer trainable parameters. Timing: 40 seconds. Source: Gayoso et al., Nature Methods 2021, doi:10.1038/s41592-020-01050-x.</a:t>
+              <a:t>We compare the published totalVI architecture with FusionVI on the paper's missing-protein benchmark. Every protein in SLN111-D2 is hidden during training, and the model predicts all 110 from RNA plus the multimodal structure learned in SLN111-D1. The final analysis uses 16 paired random seeds. The mean difference is −0.0062 RMSLE and its 95 percent interval excludes zero. Timing: 40 seconds. Source: Gayoso et al., Nature Methods 2021, doi:10.1038/s41592-020-01050-x.</a:t>
             </a:r>
           </a:p>
         </p:txBody>
@@ -729,7 +729,7 @@
           <a:lstStyle xmlns:a="http://schemas.openxmlformats.org/drawingml/2006/main"/>
           <a:p xmlns:a="http://schemas.openxmlformats.org/drawingml/2006/main">
             <a:r>
-              <a:t>For each of 4 seeds, we train one totalVI model and one FusionVI model with identical settings: at most 500 epochs, learning rate 0.004, batch size 256, 90/10 training-validation split and early stopping patience 45. Prediction averages 25 posterior samples. The primary metric is mean per-protein root mean squared log error across 7,564 D2 cells. The paper ran 30 initializations; our course benchmark runs 4 paired seeds. Timing: 60 seconds.</a:t>
+              <a:t>For each of 16 seeds, we train one totalVI model and one FusionVI model with identical settings: at most 500 epochs, learning rate 0.004, batch size 256, 90/10 training-validation split and early stopping patience 45. Prediction averages 25 posterior samples. The primary metric is mean per-protein root mean squared log error across 7,564 D2 cells. The paper ran 30 initializations; our course benchmark runs 16 paired seeds. Timing: 60 seconds.</a:t>
             </a:r>
           </a:p>
         </p:txBody>
@@ -799,7 +799,7 @@
           <a:lstStyle xmlns:a="http://schemas.openxmlformats.org/drawingml/2006/main"/>
           <a:p xmlns:a="http://schemas.openxmlformats.org/drawingml/2006/main">
             <a:r>
-              <a:t>FusionVI lowers mean RMSLE by 0.0060 across 110 proteins. The left panel connects totalVI and FusionVI results from the same random seed. The right panel compares mean error for each of 110 proteins; points below the diagonal favor FusionVI. FusionVI is lower for 74 proteins. The paired Wilcoxon value across proteins is 0.0000104, but proteins are algorithmic units rather than independent animals. Timing: 70 seconds.</a:t>
+              <a:t>Across 16 paired seeds, FusionVI lowers mean RMSLE by 0.0062 versus the published totalVI configuration. FusionVI also beats the same-width, parameter-matched and missingness-aware joint encoders. The left panel shows paired differences with 95 percent t intervals. The right panel shows one point per seed and the mean for each arm. Timing: 70 seconds.</a:t>
             </a:r>
           </a:p>
         </p:txBody>
@@ -869,7 +869,7 @@
           <a:lstStyle xmlns:a="http://schemas.openxmlformats.org/drawingml/2006/main"/>
           <a:p xmlns:a="http://schemas.openxmlformats.org/drawingml/2006/main">
             <a:r>
-              <a:t>The primary result answers the method question under the paper's exact missing-panel setup. The four-marker extension asks a related biological question in a mouse-held-out design and favors FusionVI, but it uses a different readout and remains secondary. Our evidence supports a technical benchmark claim, not clinical utility or population-level biology. Timing: 60 seconds.</a:t>
+              <a:t>The matched controls resolve the earlier capacity concern: FusionVI's small advantage persists at the same width, at similar parameter count, and against a joint encoder given the same missing-panel indicator. The RNA ridge baseline remains much stronger on aggregate RMSLE, which limits the practical claim. Timing: 60 seconds.</a:t>
             </a:r>
           </a:p>
         </p:txBody>
@@ -939,7 +939,7 @@
           <a:lstStyle xmlns:a="http://schemas.openxmlformats.org/drawingml/2006/main"/>
           <a:p xmlns:a="http://schemas.openxmlformats.org/drawingml/2006/main">
             <a:r>
-              <a:t>FusionVI lowers missing-protein reconstruction error. The direct benchmark is fair because the models share the data, decoder, likelihood and training protocol. Our conclusion remains bounded by one source-target pair and 4 rather than 30 initializations. Timing: 35 seconds, leaving three minutes for questions.</a:t>
+              <a:t>FusionVI's small neural-model advantage survives the prespecified Tier 1 controls across 16 paired seeds. The RNA SVD-ridge baseline still performs substantially better on aggregate error. The conclusion remains limited to one source-target batch pair. Timing: 35 seconds, leaving three minutes for questions.</a:t>
             </a:r>
           </a:p>
         </p:txBody>
@@ -1007,7 +1007,7 @@
   </p:cSld>
   <p:clrMap bg1="lt1" tx1="dk1" bg2="lt2" tx2="dk2" accent1="accent1" accent2="accent2" accent3="accent3" accent4="accent4" accent5="accent5" accent6="accent6" hlink="hlink" folHlink="folHlink"/>
   <p:sldLayoutIdLst>
-    <p:sldLayoutId xmlns:r="http://schemas.openxmlformats.org/officeDocument/2006/relationships" id="2147483649" r:id="R13b4466cb71a4b51"/>
+    <p:sldLayoutId xmlns:r="http://schemas.openxmlformats.org/officeDocument/2006/relationships" id="2147483649" r:id="R8878ae42d7eb45ef"/>
   </p:sldLayoutIdLst>
   <p:txStyles>
     <p:titleStyle>
@@ -1582,10 +1582,6 @@
             <a:noFill/>
           </a:ln>
         </p:spPr>
-        <p:txBody xmlns:a="http://schemas.openxmlformats.org/drawingml/2006/main">
-          <a:bodyPr/>
-          <a:p/>
-        </p:txBody>
       </p:sp>
       <p:sp>
         <p:nvSpPr>
@@ -1616,10 +1612,6 @@
             <a:noFill/>
           </a:ln>
         </p:spPr>
-        <p:txBody xmlns:a="http://schemas.openxmlformats.org/drawingml/2006/main">
-          <a:bodyPr/>
-          <a:p/>
-        </p:txBody>
       </p:sp>
       <p:sp>
         <p:nvSpPr>
@@ -1889,10 +1881,6 @@
             <a:noFill/>
           </a:ln>
         </p:spPr>
-        <p:txBody xmlns:a="http://schemas.openxmlformats.org/drawingml/2006/main">
-          <a:bodyPr/>
-          <a:p/>
-        </p:txBody>
       </p:sp>
       <p:sp>
         <p:nvSpPr>
@@ -1986,10 +1974,6 @@
             <a:noFill/>
           </a:ln>
         </p:spPr>
-        <p:txBody xmlns:a="http://schemas.openxmlformats.org/drawingml/2006/main">
-          <a:bodyPr/>
-          <a:p/>
-        </p:txBody>
       </p:sp>
       <p:sp>
         <p:nvSpPr>
@@ -2144,10 +2128,6 @@
             <a:noFill/>
           </a:ln>
         </p:spPr>
-        <p:txBody xmlns:a="http://schemas.openxmlformats.org/drawingml/2006/main">
-          <a:bodyPr/>
-          <a:p/>
-        </p:txBody>
       </p:sp>
       <p:sp>
         <p:nvSpPr>
@@ -2302,10 +2282,6 @@
             <a:noFill/>
           </a:ln>
         </p:spPr>
-        <p:txBody xmlns:a="http://schemas.openxmlformats.org/drawingml/2006/main">
-          <a:bodyPr/>
-          <a:p/>
-        </p:txBody>
       </p:sp>
       <p:sp>
         <p:nvSpPr>
@@ -2363,7 +2339,7 @@
                 <a:ea typeface="Arial"/>
                 <a:cs typeface="Arial"/>
               </a:rPr>
-              <a:t>4</a:t>
+              <a:t>16</a:t>
             </a:r>
           </a:p>
         </p:txBody>
@@ -2546,7 +2522,7 @@
                 <a:ea typeface="Arial"/>
                 <a:cs typeface="Arial"/>
               </a:rPr>
-              <a:t>−0.0060</a:t>
+              <a:t>−0.0062</a:t>
             </a:r>
           </a:p>
         </p:txBody>
@@ -2668,7 +2644,7 @@
                 <a:ea typeface="Arial"/>
                 <a:cs typeface="Arial"/>
               </a:rPr>
-              <a:t>seed CI crosses zero</a:t>
+              <a:t>95% CI excludes zero</a:t>
             </a:r>
           </a:p>
         </p:txBody>
@@ -2853,10 +2829,6 @@
             <a:noFill/>
           </a:ln>
         </p:spPr>
-        <p:txBody xmlns:a="http://schemas.openxmlformats.org/drawingml/2006/main">
-          <a:bodyPr/>
-          <a:p/>
-        </p:txBody>
       </p:sp>
       <p:sp>
         <p:nvSpPr>
@@ -3011,10 +2983,6 @@
             <a:noFill/>
           </a:ln>
         </p:spPr>
-        <p:txBody xmlns:a="http://schemas.openxmlformats.org/drawingml/2006/main">
-          <a:bodyPr/>
-          <a:p/>
-        </p:txBody>
       </p:sp>
       <p:sp>
         <p:nvSpPr>
@@ -3230,10 +3198,6 @@
             <a:noFill/>
           </a:ln>
         </p:spPr>
-        <p:txBody xmlns:a="http://schemas.openxmlformats.org/drawingml/2006/main">
-          <a:bodyPr/>
-          <a:p/>
-        </p:txBody>
       </p:sp>
       <p:sp>
         <p:nvSpPr>
@@ -3327,10 +3291,6 @@
             <a:noFill/>
           </a:ln>
         </p:spPr>
-        <p:txBody xmlns:a="http://schemas.openxmlformats.org/drawingml/2006/main">
-          <a:bodyPr/>
-          <a:p/>
-        </p:txBody>
       </p:sp>
       <p:sp>
         <p:nvSpPr>
@@ -3546,10 +3506,6 @@
             <a:noFill/>
           </a:ln>
         </p:spPr>
-        <p:txBody xmlns:a="http://schemas.openxmlformats.org/drawingml/2006/main">
-          <a:bodyPr/>
-          <a:p/>
-        </p:txBody>
       </p:sp>
       <p:sp>
         <p:nvSpPr>
@@ -3643,10 +3599,6 @@
             <a:noFill/>
           </a:ln>
         </p:spPr>
-        <p:txBody xmlns:a="http://schemas.openxmlformats.org/drawingml/2006/main">
-          <a:bodyPr/>
-          <a:p/>
-        </p:txBody>
       </p:sp>
       <p:sp>
         <p:nvSpPr>
@@ -3862,10 +3814,6 @@
             <a:noFill/>
           </a:ln>
         </p:spPr>
-        <p:txBody xmlns:a="http://schemas.openxmlformats.org/drawingml/2006/main">
-          <a:bodyPr/>
-          <a:p/>
-        </p:txBody>
       </p:sp>
       <p:sp>
         <p:nvSpPr>
@@ -3959,10 +3907,6 @@
             <a:noFill/>
           </a:ln>
         </p:spPr>
-        <p:txBody xmlns:a="http://schemas.openxmlformats.org/drawingml/2006/main">
-          <a:bodyPr/>
-          <a:p/>
-        </p:txBody>
       </p:sp>
       <p:sp>
         <p:nvSpPr>
@@ -4178,10 +4122,6 @@
             <a:noFill/>
           </a:ln>
         </p:spPr>
-        <p:txBody xmlns:a="http://schemas.openxmlformats.org/drawingml/2006/main">
-          <a:bodyPr/>
-          <a:p/>
-        </p:txBody>
       </p:sp>
       <p:sp>
         <p:nvSpPr>
@@ -4277,10 +4217,6 @@
             </a:solidFill>
           </a:ln>
         </p:spPr>
-        <p:txBody xmlns:a="http://schemas.openxmlformats.org/drawingml/2006/main">
-          <a:bodyPr/>
-          <a:p/>
-        </p:txBody>
       </p:sp>
       <p:sp>
         <p:nvSpPr>
@@ -4523,10 +4459,6 @@
             <a:noFill/>
           </a:ln>
         </p:spPr>
-        <p:txBody xmlns:a="http://schemas.openxmlformats.org/drawingml/2006/main">
-          <a:bodyPr/>
-          <a:p/>
-        </p:txBody>
       </p:sp>
       <p:sp>
         <p:nvSpPr>
@@ -4620,10 +4552,6 @@
             <a:noFill/>
           </a:ln>
         </p:spPr>
-        <p:txBody xmlns:a="http://schemas.openxmlformats.org/drawingml/2006/main">
-          <a:bodyPr/>
-          <a:p/>
-        </p:txBody>
       </p:sp>
       <p:sp>
         <p:nvSpPr>
@@ -4778,10 +4706,6 @@
             <a:noFill/>
           </a:ln>
         </p:spPr>
-        <p:txBody xmlns:a="http://schemas.openxmlformats.org/drawingml/2006/main">
-          <a:bodyPr/>
-          <a:p/>
-        </p:txBody>
       </p:sp>
       <p:sp>
         <p:nvSpPr>
@@ -4936,10 +4860,6 @@
             <a:noFill/>
           </a:ln>
         </p:spPr>
-        <p:txBody xmlns:a="http://schemas.openxmlformats.org/drawingml/2006/main">
-          <a:bodyPr/>
-          <a:p/>
-        </p:txBody>
       </p:sp>
       <p:sp>
         <p:nvSpPr>
@@ -5094,10 +5014,6 @@
             <a:noFill/>
           </a:ln>
         </p:spPr>
-        <p:txBody xmlns:a="http://schemas.openxmlformats.org/drawingml/2006/main">
-          <a:bodyPr/>
-          <a:p/>
-        </p:txBody>
       </p:sp>
       <p:sp>
         <p:nvSpPr>
@@ -5252,10 +5168,6 @@
             <a:noFill/>
           </a:ln>
         </p:spPr>
-        <p:txBody xmlns:a="http://schemas.openxmlformats.org/drawingml/2006/main">
-          <a:bodyPr/>
-          <a:p/>
-        </p:txBody>
       </p:sp>
       <p:sp>
         <p:nvSpPr>
@@ -5412,10 +5324,6 @@
             </a:solidFill>
           </a:ln>
         </p:spPr>
-        <p:txBody xmlns:a="http://schemas.openxmlformats.org/drawingml/2006/main">
-          <a:bodyPr/>
-          <a:p/>
-        </p:txBody>
       </p:sp>
       <p:sp>
         <p:nvSpPr>
@@ -5721,10 +5629,6 @@
             </a:solidFill>
           </a:ln>
         </p:spPr>
-        <p:txBody xmlns:a="http://schemas.openxmlformats.org/drawingml/2006/main">
-          <a:bodyPr/>
-          <a:p/>
-        </p:txBody>
       </p:sp>
       <p:sp>
         <p:nvSpPr>
@@ -6265,7 +6169,7 @@
                 <a:ea typeface="Arial"/>
                 <a:cs typeface="Arial"/>
               </a:rPr>
-              <a:t>Architecture proposal and controls</a:t>
+              <a:t>One controlled architectural change</a:t>
             </a:r>
           </a:p>
         </p:txBody>
@@ -6299,10 +6203,6 @@
             <a:noFill/>
           </a:ln>
         </p:spPr>
-        <p:txBody xmlns:a="http://schemas.openxmlformats.org/drawingml/2006/main">
-          <a:bodyPr/>
-          <a:p/>
-        </p:txBody>
       </p:sp>
       <p:sp>
         <p:nvSpPr>
@@ -6398,10 +6298,6 @@
             </a:solidFill>
           </a:ln>
         </p:spPr>
-        <p:txBody xmlns:a="http://schemas.openxmlformats.org/drawingml/2006/main">
-          <a:bodyPr/>
-          <a:p/>
-        </p:txBody>
       </p:sp>
       <p:sp>
         <p:nvSpPr>
@@ -6678,10 +6574,6 @@
             <a:noFill/>
           </a:ln>
         </p:spPr>
-        <p:txBody xmlns:a="http://schemas.openxmlformats.org/drawingml/2006/main">
-          <a:bodyPr/>
-          <a:p/>
-        </p:txBody>
       </p:sp>
       <p:sp>
         <p:nvSpPr>
@@ -6838,10 +6730,6 @@
             </a:solidFill>
           </a:ln>
         </p:spPr>
-        <p:txBody xmlns:a="http://schemas.openxmlformats.org/drawingml/2006/main">
-          <a:bodyPr/>
-          <a:p/>
-        </p:txBody>
       </p:sp>
       <p:sp>
         <p:nvSpPr>
@@ -6998,10 +6886,6 @@
             </a:solidFill>
           </a:ln>
         </p:spPr>
-        <p:txBody xmlns:a="http://schemas.openxmlformats.org/drawingml/2006/main">
-          <a:bodyPr/>
-          <a:p/>
-        </p:txBody>
       </p:sp>
       <p:sp>
         <p:nvSpPr>
@@ -7156,10 +7040,6 @@
             <a:noFill/>
           </a:ln>
         </p:spPr>
-        <p:txBody xmlns:a="http://schemas.openxmlformats.org/drawingml/2006/main">
-          <a:bodyPr/>
-          <a:p/>
-        </p:txBody>
       </p:sp>
       <p:sp>
         <p:nvSpPr>
@@ -7192,10 +7072,6 @@
             <a:noFill/>
           </a:ln>
         </p:spPr>
-        <p:txBody xmlns:a="http://schemas.openxmlformats.org/drawingml/2006/main">
-          <a:bodyPr/>
-          <a:p/>
-        </p:txBody>
       </p:sp>
       <p:sp>
         <p:nvSpPr>
@@ -7474,10 +7350,6 @@
             </a:solidFill>
           </a:ln>
         </p:spPr>
-        <p:txBody xmlns:a="http://schemas.openxmlformats.org/drawingml/2006/main">
-          <a:bodyPr/>
-          <a:p/>
-        </p:txBody>
       </p:sp>
       <p:sp>
         <p:nvSpPr>
@@ -7718,7 +7590,7 @@
                 <a:ea typeface="Arial"/>
                 <a:cs typeface="Arial"/>
               </a:rPr>
-              <a:t>Original widths differ; controls isolate fusion and missing-input handling</a:t>
+              <a:t>Only the encoder changes; missing panel routes to RNA only</a:t>
             </a:r>
           </a:p>
         </p:txBody>
@@ -7869,7 +7741,7 @@
                 <a:ea typeface="Arial"/>
                 <a:cs typeface="Arial"/>
               </a:rPr>
-              <a:t>Paired seeds control random initialization</a:t>
+              <a:t>Paired training controls the comparison</a:t>
             </a:r>
           </a:p>
         </p:txBody>
@@ -7903,10 +7775,6 @@
             <a:noFill/>
           </a:ln>
         </p:spPr>
-        <p:txBody xmlns:a="http://schemas.openxmlformats.org/drawingml/2006/main">
-          <a:bodyPr/>
-          <a:p/>
-        </p:txBody>
       </p:sp>
       <p:sp>
         <p:nvSpPr>
@@ -8002,10 +7870,6 @@
             </a:solidFill>
           </a:ln>
         </p:spPr>
-        <p:txBody xmlns:a="http://schemas.openxmlformats.org/drawingml/2006/main">
-          <a:bodyPr/>
-          <a:p/>
-        </p:txBody>
       </p:sp>
       <p:sp>
         <p:nvSpPr>
@@ -8467,10 +8331,6 @@
             </a:solidFill>
           </a:ln>
         </p:spPr>
-        <p:txBody xmlns:a="http://schemas.openxmlformats.org/drawingml/2006/main">
-          <a:bodyPr/>
-          <a:p/>
-        </p:txBody>
       </p:sp>
       <p:sp>
         <p:nvSpPr>
@@ -8930,10 +8790,6 @@
             <a:noFill/>
           </a:ln>
         </p:spPr>
-        <p:txBody xmlns:a="http://schemas.openxmlformats.org/drawingml/2006/main">
-          <a:bodyPr/>
-          <a:p/>
-        </p:txBody>
       </p:sp>
       <p:sp>
         <p:nvSpPr>
@@ -9088,10 +8944,6 @@
             <a:noFill/>
           </a:ln>
         </p:spPr>
-        <p:txBody xmlns:a="http://schemas.openxmlformats.org/drawingml/2006/main">
-          <a:bodyPr/>
-          <a:p/>
-        </p:txBody>
       </p:sp>
       <p:sp>
         <p:nvSpPr>
@@ -9246,10 +9098,6 @@
             <a:noFill/>
           </a:ln>
         </p:spPr>
-        <p:txBody xmlns:a="http://schemas.openxmlformats.org/drawingml/2006/main">
-          <a:bodyPr/>
-          <a:p/>
-        </p:txBody>
       </p:sp>
       <p:sp>
         <p:nvSpPr>
@@ -9519,7 +9367,7 @@
                 <a:ea typeface="Arial"/>
                 <a:cs typeface="Arial"/>
               </a:rPr>
-              <a:t>Small mean difference; uncertainty spans zero</a:t>
+              <a:t>FusionVI advantage survives matched controls</a:t>
             </a:r>
           </a:p>
         </p:txBody>
@@ -9553,10 +9401,6 @@
             <a:noFill/>
           </a:ln>
         </p:spPr>
-        <p:txBody xmlns:a="http://schemas.openxmlformats.org/drawingml/2006/main">
-          <a:bodyPr/>
-          <a:p/>
-        </p:txBody>
       </p:sp>
       <p:sp>
         <p:nvSpPr>
@@ -9628,13 +9472,13 @@
           <p:nvPr/>
         </p:nvPicPr>
         <p:blipFill>
-          <a:blip xmlns:r="http://schemas.openxmlformats.org/officeDocument/2006/relationships" xmlns:a="http://schemas.openxmlformats.org/drawingml/2006/main" r:embed="R2730fe664fc14684"/>
+          <a:blip xmlns:r="http://schemas.openxmlformats.org/officeDocument/2006/relationships" xmlns:a="http://schemas.openxmlformats.org/drawingml/2006/main" r:embed="R90a5dc8921804d6b"/>
           <a:stretch xmlns:a="http://schemas.openxmlformats.org/drawingml/2006/main"/>
         </p:blipFill>
         <p:spPr>
           <a:xfrm xmlns:a="http://schemas.openxmlformats.org/drawingml/2006/main">
-            <a:off x="592814" y="1796191"/>
-            <a:ext cx="7996471" cy="3951418"/>
+            <a:off x="400050" y="2153902"/>
+            <a:ext cx="8382000" cy="3235996"/>
           </a:xfrm>
           <a:prstGeom xmlns:a="http://schemas.openxmlformats.org/drawingml/2006/main" prst="rect">
             <a:avLst/>
@@ -9674,10 +9518,6 @@
             </a:solidFill>
           </a:ln>
         </p:spPr>
-        <p:txBody xmlns:a="http://schemas.openxmlformats.org/drawingml/2006/main">
-          <a:bodyPr/>
-          <a:p/>
-        </p:txBody>
       </p:sp>
       <p:sp>
         <p:nvSpPr>
@@ -9735,7 +9575,7 @@
                 <a:ea typeface="Arial"/>
                 <a:cs typeface="Arial"/>
               </a:rPr>
-              <a:t>−0.0060</a:t>
+              <a:t>−0.0062</a:t>
             </a:r>
           </a:p>
         </p:txBody>
@@ -9857,7 +9697,7 @@
                 <a:ea typeface="Arial"/>
                 <a:cs typeface="Arial"/>
               </a:rPr>
-              <a:t>1.0605  |  1.0544</a:t>
+              <a:t>1.0601  |  1.0539</a:t>
             </a:r>
           </a:p>
         </p:txBody>
@@ -9895,10 +9735,6 @@
             </a:solidFill>
           </a:ln>
         </p:spPr>
-        <p:txBody xmlns:a="http://schemas.openxmlformats.org/drawingml/2006/main">
-          <a:bodyPr/>
-          <a:p/>
-        </p:txBody>
       </p:sp>
       <p:sp>
         <p:nvSpPr>
@@ -9956,7 +9792,7 @@
                 <a:ea typeface="Arial"/>
                 <a:cs typeface="Arial"/>
               </a:rPr>
-              <a:t>Protein-level comparison</a:t>
+              <a:t>Matched joint encoders</a:t>
             </a:r>
           </a:p>
         </p:txBody>
@@ -9990,7 +9826,7 @@
         </p:spPr>
         <p:txBody>
           <a:bodyPr xmlns:a="http://schemas.openxmlformats.org/drawingml/2006/main" anchor="ctr">
-            <a:normAutofit fontScale="84002"/>
+            <a:normAutofit fontScale="76877"/>
           </a:bodyPr>
           <a:lstStyle xmlns:a="http://schemas.openxmlformats.org/drawingml/2006/main"/>
           <a:p xmlns:a="http://schemas.openxmlformats.org/drawingml/2006/main">
@@ -10017,7 +9853,7 @@
                 <a:ea typeface="Arial"/>
                 <a:cs typeface="Arial"/>
               </a:rPr>
-              <a:t>FusionVI lower</a:t>
+              <a:t>Same width   -0.0106</a:t>
             </a:r>
           </a:p>
           <a:p xmlns:a="http://schemas.openxmlformats.org/drawingml/2006/main">
@@ -10044,7 +9880,7 @@
                 <a:ea typeface="Arial"/>
                 <a:cs typeface="Arial"/>
               </a:rPr>
-              <a:t>for 74/110 proteins</a:t>
+              <a:t>Same parameters   -0.0189</a:t>
             </a:r>
           </a:p>
           <a:p xmlns:a="http://schemas.openxmlformats.org/drawingml/2006/main">
@@ -10071,34 +9907,7 @@
                 <a:ea typeface="Arial"/>
                 <a:cs typeface="Arial"/>
               </a:rPr>
-              <a:t/>
-            </a:r>
-          </a:p>
-          <a:p xmlns:a="http://schemas.openxmlformats.org/drawingml/2006/main">
-            <a:pPr algn="l">
-              <a:lnSpc>
-                <a:spcPct val="104000"/>
-              </a:lnSpc>
-              <a:buNone/>
-              <a:defRPr sz="1725" b="1">
-                <a:solidFill>
-                  <a:srgbClr val="172554"/>
-                </a:solidFill>
-                <a:latin typeface="Arial"/>
-                <a:ea typeface="Arial"/>
-                <a:cs typeface="Arial"/>
-              </a:defRPr>
-            </a:pPr>
-            <a:r>
-              <a:rPr sz="1725" b="1">
-                <a:solidFill>
-                  <a:srgbClr val="172554"/>
-                </a:solidFill>
-                <a:latin typeface="Arial"/>
-                <a:ea typeface="Arial"/>
-                <a:cs typeface="Arial"/>
-              </a:rPr>
-              <a:t>seed-level p = 0.20</a:t>
+              <a:t>+ availability   -0.0112</a:t>
             </a:r>
           </a:p>
         </p:txBody>
@@ -10132,7 +9941,7 @@
         </p:spPr>
         <p:txBody>
           <a:bodyPr xmlns:a="http://schemas.openxmlformats.org/drawingml/2006/main" anchor="t">
-            <a:normAutofit fontScale="79591"/>
+            <a:normAutofit fontScale="68409"/>
           </a:bodyPr>
           <a:lstStyle xmlns:a="http://schemas.openxmlformats.org/drawingml/2006/main"/>
           <a:p xmlns:a="http://schemas.openxmlformats.org/drawingml/2006/main">
@@ -10159,7 +9968,7 @@
                 <a:ea typeface="Arial"/>
                 <a:cs typeface="Arial"/>
               </a:rPr>
-              <a:t>3/4 seeds favor FusionVI  •  capacity controls running</a:t>
+              <a:t>16 paired seeds  •  matched controls complete</a:t>
             </a:r>
           </a:p>
         </p:txBody>
@@ -10310,7 +10119,7 @@
                 <a:ea typeface="Arial"/>
                 <a:cs typeface="Arial"/>
               </a:rPr>
-              <a:t>The first comparison is suggestive, not decisive</a:t>
+              <a:t>Matched controls support a small encoder advantage</a:t>
             </a:r>
           </a:p>
         </p:txBody>
@@ -10344,10 +10153,6 @@
             <a:noFill/>
           </a:ln>
         </p:spPr>
-        <p:txBody xmlns:a="http://schemas.openxmlformats.org/drawingml/2006/main">
-          <a:bodyPr/>
-          <a:p/>
-        </p:txBody>
       </p:sp>
       <p:sp>
         <p:nvSpPr>
@@ -10443,10 +10248,6 @@
             </a:solidFill>
           </a:ln>
         </p:spPr>
-        <p:txBody xmlns:a="http://schemas.openxmlformats.org/drawingml/2006/main">
-          <a:bodyPr/>
-          <a:p/>
-        </p:txBody>
       </p:sp>
       <p:sp>
         <p:nvSpPr>
@@ -10538,7 +10339,7 @@
         </p:spPr>
         <p:txBody>
           <a:bodyPr xmlns:a="http://schemas.openxmlformats.org/drawingml/2006/main" anchor="t">
-            <a:normAutofit fontScale="100000"/>
+            <a:normAutofit fontScale="95464"/>
           </a:bodyPr>
           <a:lstStyle xmlns:a="http://schemas.openxmlformats.org/drawingml/2006/main"/>
           <a:p xmlns:a="http://schemas.openxmlformats.org/drawingml/2006/main">
@@ -10565,7 +10366,7 @@
                 <a:ea typeface="Arial"/>
                 <a:cs typeface="Arial"/>
               </a:rPr>
-              <a:t>Mean RMSLE is 0.0060 lower, but the seed-level 95% CI is −0.0176 to +0.0056 (p=0.20).</a:t>
+              <a:t>Across 16 paired seeds, FusionVI lowers mean RMSLE by 0.0062 versus the published totalVI configuration. The 95 percent CI is -0.0086 to -0.0038.</a:t>
             </a:r>
           </a:p>
         </p:txBody>
@@ -10603,10 +10404,6 @@
             </a:solidFill>
           </a:ln>
         </p:spPr>
-        <p:txBody xmlns:a="http://schemas.openxmlformats.org/drawingml/2006/main">
-          <a:bodyPr/>
-          <a:p/>
-        </p:txBody>
       </p:sp>
       <p:sp>
         <p:nvSpPr>
@@ -10725,7 +10522,7 @@
                 <a:ea typeface="Arial"/>
                 <a:cs typeface="Arial"/>
               </a:rPr>
-              <a:t>The 35% gap mainly reflects width 128 versus 256 and removal of totalVI’s separate library encoder.</a:t>
+              <a:t>FusionVI lowers RMSLE by 0.0106 versus the same-width encoder and 0.0189 versus the parameter-matched encoder.</a:t>
             </a:r>
           </a:p>
         </p:txBody>
@@ -10786,7 +10583,7 @@
                 <a:ea typeface="Arial"/>
                 <a:cs typeface="Arial"/>
               </a:rPr>
-              <a:t>Secondary marker extension</a:t>
+              <a:t>Simple RNA baseline</a:t>
             </a:r>
           </a:p>
         </p:txBody>
@@ -10820,7 +10617,7 @@
         </p:spPr>
         <p:txBody>
           <a:bodyPr xmlns:a="http://schemas.openxmlformats.org/drawingml/2006/main" anchor="t">
-            <a:normAutofit fontScale="88034"/>
+            <a:normAutofit fontScale="100000"/>
           </a:bodyPr>
           <a:lstStyle xmlns:a="http://schemas.openxmlformats.org/drawingml/2006/main"/>
           <a:p xmlns:a="http://schemas.openxmlformats.org/drawingml/2006/main">
@@ -10847,7 +10644,7 @@
                 <a:ea typeface="Arial"/>
                 <a:cs typeface="Arial"/>
               </a:rPr>
-              <a:t>The X readout reached 0.673, while protein context + matching RNA already reached 0.670.</a:t>
+              <a:t>RNA SVD-ridge reaches RMSLE 0.6379, substantially below every neural model.</a:t>
             </a:r>
           </a:p>
         </p:txBody>
@@ -10942,7 +10739,7 @@
         </p:spPr>
         <p:txBody>
           <a:bodyPr xmlns:a="http://schemas.openxmlformats.org/drawingml/2006/main" anchor="t">
-            <a:normAutofit fontScale="96882"/>
+            <a:normAutofit fontScale="100000"/>
           </a:bodyPr>
           <a:lstStyle xmlns:a="http://schemas.openxmlformats.org/drawingml/2006/main"/>
           <a:p xmlns:a="http://schemas.openxmlformats.org/drawingml/2006/main">
@@ -10969,7 +10766,7 @@
                 <a:ea typeface="Arial"/>
                 <a:cs typeface="Arial"/>
               </a:rPr>
-              <a:t>Same-width, parameter-matched and missingness-aware controls are needed before attributing the effect to fusion.</a:t>
+              <a:t>One source-target batch pair and 16 seeds support an algorithmic comparison, not population or clinical generalization.</a:t>
             </a:r>
           </a:p>
         </p:txBody>
@@ -11093,7 +10890,7 @@
         </p:spPr>
         <p:txBody>
           <a:bodyPr xmlns:a="http://schemas.openxmlformats.org/drawingml/2006/main" anchor="t">
-            <a:normAutofit fontScale="98823"/>
+            <a:normAutofit fontScale="78908"/>
           </a:bodyPr>
           <a:lstStyle xmlns:a="http://schemas.openxmlformats.org/drawingml/2006/main"/>
           <a:p xmlns:a="http://schemas.openxmlformats.org/drawingml/2006/main">
@@ -11120,7 +10917,7 @@
                 <a:ea typeface="Arial"/>
                 <a:cs typeface="Arial"/>
               </a:rPr>
-              <a:t>Small mean difference; uncertainty spans zero</a:t>
+              <a:t>FusionVI wins the neural comparison; RNA ridge remains stronger</a:t>
             </a:r>
           </a:p>
         </p:txBody>
@@ -11154,10 +10951,6 @@
             <a:noFill/>
           </a:ln>
         </p:spPr>
-        <p:txBody xmlns:a="http://schemas.openxmlformats.org/drawingml/2006/main">
-          <a:bodyPr/>
-          <a:p/>
-        </p:txBody>
       </p:sp>
       <p:sp>
         <p:nvSpPr>
@@ -11215,7 +11008,7 @@
                 <a:ea typeface="Arial"/>
                 <a:cs typeface="Arial"/>
               </a:rPr>
-              <a:t>1.0605</a:t>
+              <a:t>1.0601</a:t>
             </a:r>
           </a:p>
         </p:txBody>
@@ -11398,7 +11191,7 @@
                 <a:ea typeface="Arial"/>
                 <a:cs typeface="Arial"/>
               </a:rPr>
-              <a:t>1.0544</a:t>
+              <a:t>1.0539</a:t>
             </a:r>
           </a:p>
         </p:txBody>
@@ -11554,7 +11347,7 @@
         </p:spPr>
         <p:txBody>
           <a:bodyPr xmlns:a="http://schemas.openxmlformats.org/drawingml/2006/main" anchor="t">
-            <a:normAutofit fontScale="92657"/>
+            <a:normAutofit fontScale="98209"/>
           </a:bodyPr>
           <a:lstStyle xmlns:a="http://schemas.openxmlformats.org/drawingml/2006/main"/>
           <a:p xmlns:a="http://schemas.openxmlformats.org/drawingml/2006/main">
@@ -11581,7 +11374,7 @@
                 <a:ea typeface="Arial"/>
                 <a:cs typeface="Arial"/>
               </a:rPr>
-              <a:t>FusionVI is 0.0060 lower on average, but four paired seeds do not show a reliable advantage.</a:t>
+              <a:t>Across 16 seeds, FusionVI beats totalVI and all three matched joint-encoder controls on mean protein RMSLE.</a:t>
             </a:r>
           </a:p>
         </p:txBody>
@@ -11642,7 +11435,7 @@
                 <a:ea typeface="Arial"/>
                 <a:cs typeface="Arial"/>
               </a:rPr>
-              <a:t>Next decisive test</a:t>
+              <a:t>Practical benchmark result</a:t>
             </a:r>
           </a:p>
         </p:txBody>
@@ -11676,7 +11469,7 @@
         </p:spPr>
         <p:txBody>
           <a:bodyPr xmlns:a="http://schemas.openxmlformats.org/drawingml/2006/main" anchor="t">
-            <a:normAutofit fontScale="83228"/>
+            <a:normAutofit fontScale="77457"/>
           </a:bodyPr>
           <a:lstStyle xmlns:a="http://schemas.openxmlformats.org/drawingml/2006/main"/>
           <a:p xmlns:a="http://schemas.openxmlformats.org/drawingml/2006/main">
@@ -11703,7 +11496,7 @@
                 <a:ea typeface="Arial"/>
                 <a:cs typeface="Arial"/>
               </a:rPr>
-              <a:t>Finish ≥14 paired seeds plus same-width, parameter-matched and missingness-aware totalVI controls.</a:t>
+              <a:t>RNA SVD-ridge reaches 0.6379 RMSLE versus 1.0539 for FusionVI, so the neural advantage is small within a weaker model family.</a:t>
             </a:r>
           </a:p>
         </p:txBody>

</xml_diff>

<commit_message>
Complete calibrated FusionVI evaluation and deliverables
</commit_message>
<xml_diff>
--- a/deliverables/FusionVI_Paper_Benchmark_Presentation.pptx
+++ b/deliverables/FusionVI_Paper_Benchmark_Presentation.pptx
@@ -2,20 +2,20 @@
 <file path=ppt/presentation.xml><?xml version="1.0" encoding="utf-8"?>
 <p:presentation xmlns:p="http://schemas.openxmlformats.org/presentationml/2006/main">
   <p:sldMasterIdLst>
-    <p:sldMasterId xmlns:r="http://schemas.openxmlformats.org/officeDocument/2006/relationships" id="2147483648" r:id="R379c69cf10594c17"/>
+    <p:sldMasterId xmlns:r="http://schemas.openxmlformats.org/officeDocument/2006/relationships" id="2147483648" r:id="R52ec499024024b48"/>
   </p:sldMasterIdLst>
   <p:notesMasterIdLst>
-    <p:notesMasterId xmlns:r="http://schemas.openxmlformats.org/officeDocument/2006/relationships" r:id="R8d89a15868a349f2"/>
+    <p:notesMasterId xmlns:r="http://schemas.openxmlformats.org/officeDocument/2006/relationships" r:id="Rbf926d1968c945d7"/>
   </p:notesMasterIdLst>
   <p:sldIdLst>
-    <p:sldId xmlns:r="http://schemas.openxmlformats.org/officeDocument/2006/relationships" id="256" r:id="R5c87a300dbf047bd"/>
-    <p:sldId xmlns:r="http://schemas.openxmlformats.org/officeDocument/2006/relationships" id="257" r:id="R5e8fc275d6824925"/>
-    <p:sldId xmlns:r="http://schemas.openxmlformats.org/officeDocument/2006/relationships" id="258" r:id="R52fe821d883845f9"/>
-    <p:sldId xmlns:r="http://schemas.openxmlformats.org/officeDocument/2006/relationships" id="259" r:id="R5f6dc134e8e14caa"/>
-    <p:sldId xmlns:r="http://schemas.openxmlformats.org/officeDocument/2006/relationships" id="260" r:id="R65c5d2b398534939"/>
-    <p:sldId xmlns:r="http://schemas.openxmlformats.org/officeDocument/2006/relationships" id="261" r:id="Rfb5d4caa1bc84858"/>
-    <p:sldId xmlns:r="http://schemas.openxmlformats.org/officeDocument/2006/relationships" id="262" r:id="R133cd76dcfb64564"/>
-    <p:sldId xmlns:r="http://schemas.openxmlformats.org/officeDocument/2006/relationships" id="263" r:id="Reee626a9a12440c4"/>
+    <p:sldId xmlns:r="http://schemas.openxmlformats.org/officeDocument/2006/relationships" id="256" r:id="R33ebf886863d496c"/>
+    <p:sldId xmlns:r="http://schemas.openxmlformats.org/officeDocument/2006/relationships" id="257" r:id="R697fdedd398d4577"/>
+    <p:sldId xmlns:r="http://schemas.openxmlformats.org/officeDocument/2006/relationships" id="258" r:id="Recc85faca5e94652"/>
+    <p:sldId xmlns:r="http://schemas.openxmlformats.org/officeDocument/2006/relationships" id="259" r:id="Re93fd9ea2fe24e1d"/>
+    <p:sldId xmlns:r="http://schemas.openxmlformats.org/officeDocument/2006/relationships" id="260" r:id="R3ddc6f752b3e4e73"/>
+    <p:sldId xmlns:r="http://schemas.openxmlformats.org/officeDocument/2006/relationships" id="261" r:id="R5aedf9d8d23f471c"/>
+    <p:sldId xmlns:r="http://schemas.openxmlformats.org/officeDocument/2006/relationships" id="262" r:id="R62570c88fb3e4ab2"/>
+    <p:sldId xmlns:r="http://schemas.openxmlformats.org/officeDocument/2006/relationships" id="263" r:id="Rddd3332a1b3344e2"/>
   </p:sldIdLst>
   <p:sldSz cx="12192000" cy="6858000"/>
   <p:notesSz cx="6858000" cy="9144000"/>
@@ -449,7 +449,7 @@
           <a:lstStyle xmlns:a="http://schemas.openxmlformats.org/drawingml/2006/main"/>
           <a:p xmlns:a="http://schemas.openxmlformats.org/drawingml/2006/main">
             <a:r>
-              <a:t>We compare the published totalVI architecture with FusionVI on the paper's missing-protein benchmark. Every protein in SLN111-D2 is hidden during training, and the model predicts all 110 from RNA plus the multimodal structure learned in SLN111-D1. The final analysis uses 16 paired random seeds. The mean difference is −0.0062 RMSLE and its 95 percent interval excludes zero. Timing: 40 seconds. Source: Gayoso et al., Nature Methods 2021, doi:10.1038/s41592-020-01050-x.</a:t>
+              <a:t>We compare the published totalVI architecture with FusionVI on the paper's missing-protein benchmark. Every protein in SLN111-D2 is hidden during training, and the model predicts all 110 from RNA plus the multimodal structure learned in SLN111-D1. Across 16 paired seeds, FusionVI's original RMSLE lead disappears after a D1-only affine calibration: the calibrated difference is +0.0085 and its 95 percent interval crosses zero. Timing: 40 seconds. Source: Gayoso et al., Nature Methods 2021, doi:10.1038/s41592-020-01050-x.</a:t>
             </a:r>
           </a:p>
         </p:txBody>
@@ -799,7 +799,7 @@
           <a:lstStyle xmlns:a="http://schemas.openxmlformats.org/drawingml/2006/main"/>
           <a:p xmlns:a="http://schemas.openxmlformats.org/drawingml/2006/main">
             <a:r>
-              <a:t>Across 16 paired seeds, FusionVI lowers mean RMSLE by 0.0062 versus the published totalVI configuration. FusionVI also beats the same-width, parameter-matched and missingness-aware joint encoders. The left panel shows paired differences with 95 percent t intervals. The right panel shows one point per seed and the mean for each arm. Timing: 70 seconds.</a:t>
+              <a:t>The original log-of-mean readout favours FusionVI, but both posterior E[log1p y] and D1-only calibration reduce the difference. After calibration, totalVI is numerically better by 0.0085 RMSLE and the confidence interval crosses zero. Calibration removes mean bias without improving residual or within-cell-type recovery for FusionVI. Timing: 70 seconds.</a:t>
             </a:r>
           </a:p>
         </p:txBody>
@@ -869,7 +869,7 @@
           <a:lstStyle xmlns:a="http://schemas.openxmlformats.org/drawingml/2006/main"/>
           <a:p xmlns:a="http://schemas.openxmlformats.org/drawingml/2006/main">
             <a:r>
-              <a:t>The matched controls resolve the earlier capacity concern: FusionVI's small advantage persists at the same width, at similar parameter count, and against a joint encoder given the same missing-panel indicator. The RNA ridge baseline remains much stronger on aggregate RMSLE, which limits the practical claim. Timing: 60 seconds.</a:t>
+              <a:t>Matched controls first showed that the raw RMSLE difference was reproducible. The scale-matched evaluation then changed its interpretation: calibration removes the advantage, residual error is higher, and within-cell-type rank recovery is slightly lower for FusionVI. Timing: 60 seconds.</a:t>
             </a:r>
           </a:p>
         </p:txBody>
@@ -939,7 +939,7 @@
           <a:lstStyle xmlns:a="http://schemas.openxmlformats.org/drawingml/2006/main"/>
           <a:p xmlns:a="http://schemas.openxmlformats.org/drawingml/2006/main">
             <a:r>
-              <a:t>FusionVI's small neural-model advantage survives the prespecified Tier 1 controls across 16 paired seeds. The RNA SVD-ridge baseline still performs substantially better on aggregate error. The conclusion remains limited to one source-target batch pair. Timing: 35 seconds, leaving three minutes for questions.</a:t>
+              <a:t>FusionVI's original-scale RMSLE advantage is reproducible, but it does not survive D1-only calibration and is not supported by residual or within-cell-type metrics. The useful contribution is the diagnostic: evaluation scale can reverse conclusions in missing-protein benchmarks. Timing: 35 seconds, leaving three minutes for questions.</a:t>
             </a:r>
           </a:p>
         </p:txBody>
@@ -1007,7 +1007,7 @@
   </p:cSld>
   <p:clrMap bg1="lt1" tx1="dk1" bg2="lt2" tx2="dk2" accent1="accent1" accent2="accent2" accent3="accent3" accent4="accent4" accent5="accent5" accent6="accent6" hlink="hlink" folHlink="folHlink"/>
   <p:sldLayoutIdLst>
-    <p:sldLayoutId xmlns:r="http://schemas.openxmlformats.org/officeDocument/2006/relationships" id="2147483649" r:id="R8878ae42d7eb45ef"/>
+    <p:sldLayoutId xmlns:r="http://schemas.openxmlformats.org/officeDocument/2006/relationships" id="2147483649" r:id="R8e6040c91bdc4bf3"/>
   </p:sldLayoutIdLst>
   <p:txStyles>
     <p:titleStyle>
@@ -1845,7 +1845,7 @@
                 <a:ea typeface="Arial"/>
                 <a:cs typeface="Arial"/>
               </a:rPr>
-              <a:t>Published totalVI versus our FusionVI encoder</a:t>
+              <a:t>Published totalVI versus FusionVI after scale matching</a:t>
             </a:r>
           </a:p>
         </p:txBody>
@@ -2522,7 +2522,7 @@
                 <a:ea typeface="Arial"/>
                 <a:cs typeface="Arial"/>
               </a:rPr>
-              <a:t>−0.0062</a:t>
+              <a:t>+0.0085</a:t>
             </a:r>
           </a:p>
         </p:txBody>
@@ -2583,7 +2583,7 @@
                 <a:ea typeface="Arial"/>
                 <a:cs typeface="Arial"/>
               </a:rPr>
-              <a:t>FusionVI − totalVI RMSLE</a:t>
+              <a:t>calibrated FusionVI − totalVI</a:t>
             </a:r>
           </a:p>
         </p:txBody>
@@ -2644,7 +2644,7 @@
                 <a:ea typeface="Arial"/>
                 <a:cs typeface="Arial"/>
               </a:rPr>
-              <a:t>95% CI excludes zero</a:t>
+              <a:t>95% CI crosses zero</a:t>
             </a:r>
           </a:p>
         </p:txBody>
@@ -9367,7 +9367,7 @@
                 <a:ea typeface="Arial"/>
                 <a:cs typeface="Arial"/>
               </a:rPr>
-              <a:t>FusionVI advantage survives matched controls</a:t>
+              <a:t>Scale matching changes the conclusion</a:t>
             </a:r>
           </a:p>
         </p:txBody>
@@ -9472,13 +9472,13 @@
           <p:nvPr/>
         </p:nvPicPr>
         <p:blipFill>
-          <a:blip xmlns:r="http://schemas.openxmlformats.org/officeDocument/2006/relationships" xmlns:a="http://schemas.openxmlformats.org/drawingml/2006/main" r:embed="R90a5dc8921804d6b"/>
+          <a:blip xmlns:r="http://schemas.openxmlformats.org/officeDocument/2006/relationships" xmlns:a="http://schemas.openxmlformats.org/drawingml/2006/main" r:embed="Rda85e4ac152340a7"/>
           <a:stretch xmlns:a="http://schemas.openxmlformats.org/drawingml/2006/main"/>
         </p:blipFill>
         <p:spPr>
           <a:xfrm xmlns:a="http://schemas.openxmlformats.org/drawingml/2006/main">
-            <a:off x="400050" y="2153902"/>
-            <a:ext cx="8382000" cy="3235996"/>
+            <a:off x="400050" y="2362733"/>
+            <a:ext cx="8382000" cy="2818333"/>
           </a:xfrm>
           <a:prstGeom xmlns:a="http://schemas.openxmlformats.org/drawingml/2006/main" prst="rect">
             <a:avLst/>
@@ -9575,7 +9575,7 @@
                 <a:ea typeface="Arial"/>
                 <a:cs typeface="Arial"/>
               </a:rPr>
-              <a:t>−0.0062</a:t>
+              <a:t>+0.0085</a:t>
             </a:r>
           </a:p>
         </p:txBody>
@@ -9636,7 +9636,7 @@
                 <a:ea typeface="Arial"/>
                 <a:cs typeface="Arial"/>
               </a:rPr>
-              <a:t>FusionVI − totalVI RMSLE</a:t>
+              <a:t>calibrated RMSLE difference</a:t>
             </a:r>
           </a:p>
         </p:txBody>
@@ -9697,7 +9697,7 @@
                 <a:ea typeface="Arial"/>
                 <a:cs typeface="Arial"/>
               </a:rPr>
-              <a:t>1.0601  |  1.0539</a:t>
+              <a:t>0.5745  |  0.5831</a:t>
             </a:r>
           </a:p>
         </p:txBody>
@@ -9792,7 +9792,7 @@
                 <a:ea typeface="Arial"/>
                 <a:cs typeface="Arial"/>
               </a:rPr>
-              <a:t>Matched joint encoders</a:t>
+              <a:t>FusionVI − totalVI</a:t>
             </a:r>
           </a:p>
         </p:txBody>
@@ -9826,7 +9826,7 @@
         </p:spPr>
         <p:txBody>
           <a:bodyPr xmlns:a="http://schemas.openxmlformats.org/drawingml/2006/main" anchor="ctr">
-            <a:normAutofit fontScale="76877"/>
+            <a:normAutofit fontScale="82480"/>
           </a:bodyPr>
           <a:lstStyle xmlns:a="http://schemas.openxmlformats.org/drawingml/2006/main"/>
           <a:p xmlns:a="http://schemas.openxmlformats.org/drawingml/2006/main">
@@ -9853,7 +9853,7 @@
                 <a:ea typeface="Arial"/>
                 <a:cs typeface="Arial"/>
               </a:rPr>
-              <a:t>Same width   -0.0106</a:t>
+              <a:t>Residual SD   +0.0065</a:t>
             </a:r>
           </a:p>
           <a:p xmlns:a="http://schemas.openxmlformats.org/drawingml/2006/main">
@@ -9880,7 +9880,7 @@
                 <a:ea typeface="Arial"/>
                 <a:cs typeface="Arial"/>
               </a:rPr>
-              <a:t>Same parameters   -0.0189</a:t>
+              <a:t>Within-cell  -0.0041</a:t>
             </a:r>
           </a:p>
           <a:p xmlns:a="http://schemas.openxmlformats.org/drawingml/2006/main">
@@ -9907,7 +9907,7 @@
                 <a:ea typeface="Arial"/>
                 <a:cs typeface="Arial"/>
               </a:rPr>
-              <a:t>+ availability   -0.0112</a:t>
+              <a:t>Marker AUROC  -0.0006</a:t>
             </a:r>
           </a:p>
         </p:txBody>
@@ -9941,7 +9941,7 @@
         </p:spPr>
         <p:txBody>
           <a:bodyPr xmlns:a="http://schemas.openxmlformats.org/drawingml/2006/main" anchor="t">
-            <a:normAutofit fontScale="68409"/>
+            <a:normAutofit fontScale="72059"/>
           </a:bodyPr>
           <a:lstStyle xmlns:a="http://schemas.openxmlformats.org/drawingml/2006/main"/>
           <a:p xmlns:a="http://schemas.openxmlformats.org/drawingml/2006/main">
@@ -9968,7 +9968,7 @@
                 <a:ea typeface="Arial"/>
                 <a:cs typeface="Arial"/>
               </a:rPr>
-              <a:t>16 paired seeds  •  matched controls complete</a:t>
+              <a:t>16 paired seeds  •  all checkpoints re-scored</a:t>
             </a:r>
           </a:p>
         </p:txBody>
@@ -10119,7 +10119,7 @@
                 <a:ea typeface="Arial"/>
                 <a:cs typeface="Arial"/>
               </a:rPr>
-              <a:t>Matched controls support a small encoder advantage</a:t>
+              <a:t>Calibration explains the apparent RMSLE gain</a:t>
             </a:r>
           </a:p>
         </p:txBody>
@@ -10305,7 +10305,7 @@
                 <a:ea typeface="Arial"/>
                 <a:cs typeface="Arial"/>
               </a:rPr>
-              <a:t>Primary paper benchmark</a:t>
+              <a:t>Original readout</a:t>
             </a:r>
           </a:p>
         </p:txBody>
@@ -10339,7 +10339,7 @@
         </p:spPr>
         <p:txBody>
           <a:bodyPr xmlns:a="http://schemas.openxmlformats.org/drawingml/2006/main" anchor="t">
-            <a:normAutofit fontScale="95464"/>
+            <a:normAutofit fontScale="100000"/>
           </a:bodyPr>
           <a:lstStyle xmlns:a="http://schemas.openxmlformats.org/drawingml/2006/main"/>
           <a:p xmlns:a="http://schemas.openxmlformats.org/drawingml/2006/main">
@@ -10366,7 +10366,7 @@
                 <a:ea typeface="Arial"/>
                 <a:cs typeface="Arial"/>
               </a:rPr>
-              <a:t>Across 16 paired seeds, FusionVI lowers mean RMSLE by 0.0062 versus the published totalVI configuration. The 95 percent CI is -0.0086 to -0.0038.</a:t>
+              <a:t>FusionVI was lower by 0.0062 RMSLE when scoring log1p of expected counts.</a:t>
             </a:r>
           </a:p>
         </p:txBody>
@@ -10461,7 +10461,7 @@
                 <a:ea typeface="Arial"/>
                 <a:cs typeface="Arial"/>
               </a:rPr>
-              <a:t>Parameter efficiency</a:t>
+              <a:t>After D1 calibration</a:t>
             </a:r>
           </a:p>
         </p:txBody>
@@ -10522,7 +10522,7 @@
                 <a:ea typeface="Arial"/>
                 <a:cs typeface="Arial"/>
               </a:rPr>
-              <a:t>FusionVI lowers RMSLE by 0.0106 versus the same-width encoder and 0.0189 versus the parameter-matched encoder.</a:t>
+              <a:t>FusionVI is +0.0085 versus totalVI; the 95% CI crosses zero and residual error is higher.</a:t>
             </a:r>
           </a:p>
         </p:txBody>
@@ -10583,7 +10583,7 @@
                 <a:ea typeface="Arial"/>
                 <a:cs typeface="Arial"/>
               </a:rPr>
-              <a:t>Simple RNA baseline</a:t>
+              <a:t>Biological information</a:t>
             </a:r>
           </a:p>
         </p:txBody>
@@ -10644,7 +10644,7 @@
                 <a:ea typeface="Arial"/>
                 <a:cs typeface="Arial"/>
               </a:rPr>
-              <a:t>RNA SVD-ridge reaches RMSLE 0.6379, substantially below every neural model.</a:t>
+              <a:t>Within-cell-type Spearman is 0.164 for FusionVI versus 0.168 for totalVI.</a:t>
             </a:r>
           </a:p>
         </p:txBody>
@@ -10705,7 +10705,7 @@
                 <a:ea typeface="Arial"/>
                 <a:cs typeface="Arial"/>
               </a:rPr>
-              <a:t>Limits on the claim</a:t>
+              <a:t>Interpretation</a:t>
             </a:r>
           </a:p>
         </p:txBody>
@@ -10766,7 +10766,7 @@
                 <a:ea typeface="Arial"/>
                 <a:cs typeface="Arial"/>
               </a:rPr>
-              <a:t>One source-target batch pair and 16 seeds support an algorithmic comparison, not population or clinical generalization.</a:t>
+              <a:t>The encoder changes output scale, but this benchmark does not show stronger recovery of biological variation.</a:t>
             </a:r>
           </a:p>
         </p:txBody>
@@ -10890,7 +10890,7 @@
         </p:spPr>
         <p:txBody>
           <a:bodyPr xmlns:a="http://schemas.openxmlformats.org/drawingml/2006/main" anchor="t">
-            <a:normAutofit fontScale="78908"/>
+            <a:normAutofit fontScale="100000"/>
           </a:bodyPr>
           <a:lstStyle xmlns:a="http://schemas.openxmlformats.org/drawingml/2006/main"/>
           <a:p xmlns:a="http://schemas.openxmlformats.org/drawingml/2006/main">
@@ -10917,7 +10917,7 @@
                 <a:ea typeface="Arial"/>
                 <a:cs typeface="Arial"/>
               </a:rPr>
-              <a:t>FusionVI wins the neural comparison; RNA ridge remains stronger</a:t>
+              <a:t>FusionVI changes scale, not biological recovery</a:t>
             </a:r>
           </a:p>
         </p:txBody>
@@ -11008,7 +11008,7 @@
                 <a:ea typeface="Arial"/>
                 <a:cs typeface="Arial"/>
               </a:rPr>
-              <a:t>1.0601</a:t>
+              <a:t>0.5745</a:t>
             </a:r>
           </a:p>
         </p:txBody>
@@ -11069,7 +11069,7 @@
                 <a:ea typeface="Arial"/>
                 <a:cs typeface="Arial"/>
               </a:rPr>
-              <a:t>totalVI RMSLE</a:t>
+              <a:t>totalVI calibrated RMSLE</a:t>
             </a:r>
           </a:p>
         </p:txBody>
@@ -11191,7 +11191,7 @@
                 <a:ea typeface="Arial"/>
                 <a:cs typeface="Arial"/>
               </a:rPr>
-              <a:t>1.0539</a:t>
+              <a:t>0.5831</a:t>
             </a:r>
           </a:p>
         </p:txBody>
@@ -11252,7 +11252,7 @@
                 <a:ea typeface="Arial"/>
                 <a:cs typeface="Arial"/>
               </a:rPr>
-              <a:t>FusionVI RMSLE</a:t>
+              <a:t>FusionVI calibrated RMSLE</a:t>
             </a:r>
           </a:p>
         </p:txBody>
@@ -11347,7 +11347,7 @@
         </p:spPr>
         <p:txBody>
           <a:bodyPr xmlns:a="http://schemas.openxmlformats.org/drawingml/2006/main" anchor="t">
-            <a:normAutofit fontScale="98209"/>
+            <a:normAutofit fontScale="93450"/>
           </a:bodyPr>
           <a:lstStyle xmlns:a="http://schemas.openxmlformats.org/drawingml/2006/main"/>
           <a:p xmlns:a="http://schemas.openxmlformats.org/drawingml/2006/main">
@@ -11374,7 +11374,7 @@
                 <a:ea typeface="Arial"/>
                 <a:cs typeface="Arial"/>
               </a:rPr>
-              <a:t>Across 16 seeds, FusionVI beats totalVI and all three matched joint-encoder controls on mean protein RMSLE.</a:t>
+              <a:t>Across 16 seeds, the raw FusionVI lead disappears after source-only calibration; residual and rank metrics do not improve.</a:t>
             </a:r>
           </a:p>
         </p:txBody>
@@ -11469,7 +11469,7 @@
         </p:spPr>
         <p:txBody>
           <a:bodyPr xmlns:a="http://schemas.openxmlformats.org/drawingml/2006/main" anchor="t">
-            <a:normAutofit fontScale="77457"/>
+            <a:normAutofit fontScale="81117"/>
           </a:bodyPr>
           <a:lstStyle xmlns:a="http://schemas.openxmlformats.org/drawingml/2006/main"/>
           <a:p xmlns:a="http://schemas.openxmlformats.org/drawingml/2006/main">
@@ -11496,7 +11496,7 @@
                 <a:ea typeface="Arial"/>
                 <a:cs typeface="Arial"/>
               </a:rPr>
-              <a:t>RNA SVD-ridge reaches 0.6379 RMSLE versus 1.0539 for FusionVI, so the neural advantage is small within a weaker model family.</a:t>
+              <a:t>D1 calibration reduces neural RMSLE below RNA ridge (0.6373), showing the earlier ridge gap was also mostly scale.</a:t>
             </a:r>
           </a:p>
         </p:txBody>

</xml_diff>